<commit_message>
Final Projects data sources and updates to slides.
</commit_message>
<xml_diff>
--- a/Day14/14-paev-andmetarkus-esitlus.pptx
+++ b/Day14/14-paev-andmetarkus-esitlus.pptx
@@ -5,10 +5,10 @@
     <p:sldMasterId id="2147483648" r:id="rId4"/>
   </p:sldMasterIdLst>
   <p:notesMasterIdLst>
-    <p:notesMasterId r:id="rId26"/>
+    <p:notesMasterId r:id="rId31"/>
   </p:notesMasterIdLst>
   <p:handoutMasterIdLst>
-    <p:handoutMasterId r:id="rId27"/>
+    <p:handoutMasterId r:id="rId32"/>
   </p:handoutMasterIdLst>
   <p:sldIdLst>
     <p:sldId id="417" r:id="rId5"/>
@@ -32,30 +32,35 @@
     <p:sldId id="577" r:id="rId23"/>
     <p:sldId id="568" r:id="rId24"/>
     <p:sldId id="647" r:id="rId25"/>
+    <p:sldId id="649" r:id="rId26"/>
+    <p:sldId id="574" r:id="rId27"/>
+    <p:sldId id="645" r:id="rId28"/>
+    <p:sldId id="538" r:id="rId29"/>
+    <p:sldId id="650" r:id="rId30"/>
   </p:sldIdLst>
   <p:sldSz cx="12192000" cy="6858000"/>
   <p:notesSz cx="6858000" cy="9144000"/>
   <p:embeddedFontLst>
     <p:embeddedFont>
       <p:font typeface="Inter" panose="020B0604020202020204" charset="0"/>
-      <p:regular r:id="rId28"/>
-      <p:bold r:id="rId29"/>
+      <p:regular r:id="rId33"/>
+      <p:bold r:id="rId34"/>
     </p:embeddedFont>
     <p:embeddedFont>
       <p:font typeface="Inter Bold" panose="020B0604020202020204" charset="0"/>
-      <p:bold r:id="rId30"/>
+      <p:bold r:id="rId35"/>
     </p:embeddedFont>
     <p:embeddedFont>
       <p:font typeface="Noto Serif" panose="02020600060500020200" pitchFamily="18" charset="0"/>
-      <p:regular r:id="rId31"/>
-      <p:bold r:id="rId32"/>
-      <p:italic r:id="rId33"/>
-      <p:boldItalic r:id="rId34"/>
+      <p:regular r:id="rId36"/>
+      <p:bold r:id="rId37"/>
+      <p:italic r:id="rId38"/>
+      <p:boldItalic r:id="rId39"/>
     </p:embeddedFont>
     <p:embeddedFont>
       <p:font typeface="Poppins SemiBold" panose="00000700000000000000" pitchFamily="2" charset="0"/>
-      <p:bold r:id="rId35"/>
-      <p:boldItalic r:id="rId36"/>
+      <p:bold r:id="rId40"/>
+      <p:boldItalic r:id="rId41"/>
     </p:embeddedFont>
   </p:embeddedFontLst>
   <p:defaultTextStyle>
@@ -164,17 +169,25 @@
 </p:presentation>
 </file>
 
+<file path=ppt/revisionInfo.xml><?xml version="1.0" encoding="utf-8"?>
+<p1510:revInfo xmlns:a="http://schemas.openxmlformats.org/drawingml/2006/main" xmlns:r="http://schemas.openxmlformats.org/officeDocument/2006/relationships" xmlns:p1510="http://schemas.microsoft.com/office/powerpoint/2015/10/main">
+  <p1510:revLst>
+    <p1510:client id="{1CEC6D2C-2DE5-4622-B5C9-CE21C0F1885C}" v="4" dt="2026-04-14T08:00:40.558"/>
+  </p1510:revLst>
+</p1510:revInfo>
+</file>
+
 <file path=ppt/changesInfos/changesInfo1.xml><?xml version="1.0" encoding="utf-8"?>
 <pc:chgInfo xmlns:a="http://schemas.openxmlformats.org/drawingml/2006/main" xmlns:r="http://schemas.openxmlformats.org/officeDocument/2006/relationships" xmlns:ac="http://schemas.microsoft.com/office/drawing/2013/main/command" xmlns:pc="http://schemas.microsoft.com/office/powerpoint/2013/main/command">
   <pc:docChgLst>
     <pc:chgData name="Virve Räni" userId="161a7437-7ef4-49ec-91bf-54882f313dfe" providerId="ADAL" clId="{6D754EED-65AA-4A21-B175-6769012CF487}"/>
     <pc:docChg chg="addSld delSld modSld sldOrd">
-      <pc:chgData name="Virve Räni" userId="161a7437-7ef4-49ec-91bf-54882f313dfe" providerId="ADAL" clId="{6D754EED-65AA-4A21-B175-6769012CF487}" dt="2026-03-18T07:45:31.134" v="200" actId="47"/>
+      <pc:chgData name="Virve Räni" userId="161a7437-7ef4-49ec-91bf-54882f313dfe" providerId="ADAL" clId="{6D754EED-65AA-4A21-B175-6769012CF487}" dt="2026-04-14T08:00:46.453" v="353" actId="255"/>
       <pc:docMkLst>
         <pc:docMk/>
       </pc:docMkLst>
       <pc:sldChg chg="modSp mod">
-        <pc:chgData name="Virve Räni" userId="161a7437-7ef4-49ec-91bf-54882f313dfe" providerId="ADAL" clId="{6D754EED-65AA-4A21-B175-6769012CF487}" dt="2026-03-18T07:41:45.385" v="196" actId="20577"/>
+        <pc:chgData name="Virve Räni" userId="161a7437-7ef4-49ec-91bf-54882f313dfe" providerId="ADAL" clId="{6D754EED-65AA-4A21-B175-6769012CF487}" dt="2026-04-14T07:54:41.652" v="271"/>
         <pc:sldMkLst>
           <pc:docMk/>
           <pc:sldMk cId="1135419376" sldId="493"/>
@@ -187,8 +200,8 @@
             <ac:spMk id="2" creationId="{11F10058-A289-F9F8-2CC8-43BAABEC6F7E}"/>
           </ac:spMkLst>
         </pc:spChg>
-        <pc:graphicFrameChg chg="modGraphic">
-          <ac:chgData name="Virve Räni" userId="161a7437-7ef4-49ec-91bf-54882f313dfe" providerId="ADAL" clId="{6D754EED-65AA-4A21-B175-6769012CF487}" dt="2026-03-18T07:41:45.385" v="196" actId="20577"/>
+        <pc:graphicFrameChg chg="mod modGraphic">
+          <ac:chgData name="Virve Räni" userId="161a7437-7ef4-49ec-91bf-54882f313dfe" providerId="ADAL" clId="{6D754EED-65AA-4A21-B175-6769012CF487}" dt="2026-04-14T07:54:41.652" v="271"/>
           <ac:graphicFrameMkLst>
             <pc:docMk/>
             <pc:sldMk cId="1135419376" sldId="493"/>
@@ -196,22 +209,15 @@
           </ac:graphicFrameMkLst>
         </pc:graphicFrameChg>
       </pc:sldChg>
-      <pc:sldChg chg="del">
-        <pc:chgData name="Virve Räni" userId="161a7437-7ef4-49ec-91bf-54882f313dfe" providerId="ADAL" clId="{6D754EED-65AA-4A21-B175-6769012CF487}" dt="2026-03-18T07:45:28.416" v="197" actId="47"/>
+      <pc:sldChg chg="add">
+        <pc:chgData name="Virve Räni" userId="161a7437-7ef4-49ec-91bf-54882f313dfe" providerId="ADAL" clId="{6D754EED-65AA-4A21-B175-6769012CF487}" dt="2026-04-14T07:59:42.079" v="308"/>
         <pc:sldMkLst>
           <pc:docMk/>
-          <pc:sldMk cId="1463216859" sldId="570"/>
+          <pc:sldMk cId="1694942831" sldId="538"/>
         </pc:sldMkLst>
       </pc:sldChg>
-      <pc:sldChg chg="del">
-        <pc:chgData name="Virve Räni" userId="161a7437-7ef4-49ec-91bf-54882f313dfe" providerId="ADAL" clId="{6D754EED-65AA-4A21-B175-6769012CF487}" dt="2026-03-18T07:45:30.501" v="199" actId="47"/>
-        <pc:sldMkLst>
-          <pc:docMk/>
-          <pc:sldMk cId="2505963611" sldId="573"/>
-        </pc:sldMkLst>
-      </pc:sldChg>
-      <pc:sldChg chg="del">
-        <pc:chgData name="Virve Räni" userId="161a7437-7ef4-49ec-91bf-54882f313dfe" providerId="ADAL" clId="{6D754EED-65AA-4A21-B175-6769012CF487}" dt="2026-03-18T07:45:29.100" v="198" actId="47"/>
+      <pc:sldChg chg="add">
+        <pc:chgData name="Virve Räni" userId="161a7437-7ef4-49ec-91bf-54882f313dfe" providerId="ADAL" clId="{6D754EED-65AA-4A21-B175-6769012CF487}" dt="2026-04-14T07:59:42.079" v="308"/>
         <pc:sldMkLst>
           <pc:docMk/>
           <pc:sldMk cId="645017635" sldId="574"/>
@@ -232,22 +238,8 @@
           </ac:spMkLst>
         </pc:spChg>
       </pc:sldChg>
-      <pc:sldChg chg="del">
-        <pc:chgData name="Virve Räni" userId="161a7437-7ef4-49ec-91bf-54882f313dfe" providerId="ADAL" clId="{6D754EED-65AA-4A21-B175-6769012CF487}" dt="2026-03-18T07:09:21.196" v="151" actId="47"/>
-        <pc:sldMkLst>
-          <pc:docMk/>
-          <pc:sldMk cId="4166333113" sldId="643"/>
-        </pc:sldMkLst>
-      </pc:sldChg>
-      <pc:sldChg chg="del">
-        <pc:chgData name="Virve Räni" userId="161a7437-7ef4-49ec-91bf-54882f313dfe" providerId="ADAL" clId="{6D754EED-65AA-4A21-B175-6769012CF487}" dt="2026-03-18T07:11:23.421" v="154" actId="47"/>
-        <pc:sldMkLst>
-          <pc:docMk/>
-          <pc:sldMk cId="2066132299" sldId="644"/>
-        </pc:sldMkLst>
-      </pc:sldChg>
-      <pc:sldChg chg="del">
-        <pc:chgData name="Virve Räni" userId="161a7437-7ef4-49ec-91bf-54882f313dfe" providerId="ADAL" clId="{6D754EED-65AA-4A21-B175-6769012CF487}" dt="2026-03-18T07:45:31.134" v="200" actId="47"/>
+      <pc:sldChg chg="add">
+        <pc:chgData name="Virve Räni" userId="161a7437-7ef4-49ec-91bf-54882f313dfe" providerId="ADAL" clId="{6D754EED-65AA-4A21-B175-6769012CF487}" dt="2026-04-14T07:59:42.079" v="308"/>
         <pc:sldMkLst>
           <pc:docMk/>
           <pc:sldMk cId="1674079011" sldId="645"/>
@@ -265,6 +257,59 @@
             <pc:docMk/>
             <pc:sldMk cId="1871966603" sldId="647"/>
             <ac:spMk id="3" creationId="{0F58F04F-79CF-D596-2442-C7AA52CDBB45}"/>
+          </ac:spMkLst>
+        </pc:spChg>
+      </pc:sldChg>
+      <pc:sldChg chg="modSp new del mod">
+        <pc:chgData name="Virve Räni" userId="161a7437-7ef4-49ec-91bf-54882f313dfe" providerId="ADAL" clId="{6D754EED-65AA-4A21-B175-6769012CF487}" dt="2026-04-14T07:59:46.607" v="309" actId="47"/>
+        <pc:sldMkLst>
+          <pc:docMk/>
+          <pc:sldMk cId="3046746180" sldId="648"/>
+        </pc:sldMkLst>
+        <pc:spChg chg="mod">
+          <ac:chgData name="Virve Räni" userId="161a7437-7ef4-49ec-91bf-54882f313dfe" providerId="ADAL" clId="{6D754EED-65AA-4A21-B175-6769012CF487}" dt="2026-04-14T07:55:26.861" v="307" actId="20577"/>
+          <ac:spMkLst>
+            <pc:docMk/>
+            <pc:sldMk cId="3046746180" sldId="648"/>
+            <ac:spMk id="2" creationId="{6A72FBA8-9375-0A43-3A3A-3ADB365D7C58}"/>
+          </ac:spMkLst>
+        </pc:spChg>
+      </pc:sldChg>
+      <pc:sldChg chg="modSp add mod">
+        <pc:chgData name="Virve Räni" userId="161a7437-7ef4-49ec-91bf-54882f313dfe" providerId="ADAL" clId="{6D754EED-65AA-4A21-B175-6769012CF487}" dt="2026-04-14T07:55:19.380" v="284" actId="20577"/>
+        <pc:sldMkLst>
+          <pc:docMk/>
+          <pc:sldMk cId="3267241536" sldId="649"/>
+        </pc:sldMkLst>
+        <pc:spChg chg="mod">
+          <ac:chgData name="Virve Räni" userId="161a7437-7ef4-49ec-91bf-54882f313dfe" providerId="ADAL" clId="{6D754EED-65AA-4A21-B175-6769012CF487}" dt="2026-04-14T07:55:19.380" v="284" actId="20577"/>
+          <ac:spMkLst>
+            <pc:docMk/>
+            <pc:sldMk cId="3267241536" sldId="649"/>
+            <ac:spMk id="5" creationId="{F302593E-1699-CD76-2AB7-FB29D7F743E7}"/>
+          </ac:spMkLst>
+        </pc:spChg>
+      </pc:sldChg>
+      <pc:sldChg chg="modSp new mod">
+        <pc:chgData name="Virve Räni" userId="161a7437-7ef4-49ec-91bf-54882f313dfe" providerId="ADAL" clId="{6D754EED-65AA-4A21-B175-6769012CF487}" dt="2026-04-14T08:00:46.453" v="353" actId="255"/>
+        <pc:sldMkLst>
+          <pc:docMk/>
+          <pc:sldMk cId="1519353560" sldId="650"/>
+        </pc:sldMkLst>
+        <pc:spChg chg="mod">
+          <ac:chgData name="Virve Räni" userId="161a7437-7ef4-49ec-91bf-54882f313dfe" providerId="ADAL" clId="{6D754EED-65AA-4A21-B175-6769012CF487}" dt="2026-04-14T08:00:37.653" v="345" actId="20577"/>
+          <ac:spMkLst>
+            <pc:docMk/>
+            <pc:sldMk cId="1519353560" sldId="650"/>
+            <ac:spMk id="2" creationId="{A93AD8D0-6DB4-575E-917E-EF1716356808}"/>
+          </ac:spMkLst>
+        </pc:spChg>
+        <pc:spChg chg="mod">
+          <ac:chgData name="Virve Räni" userId="161a7437-7ef4-49ec-91bf-54882f313dfe" providerId="ADAL" clId="{6D754EED-65AA-4A21-B175-6769012CF487}" dt="2026-04-14T08:00:46.453" v="353" actId="255"/>
+          <ac:spMkLst>
+            <pc:docMk/>
+            <pc:sldMk cId="1519353560" sldId="650"/>
+            <ac:spMk id="3" creationId="{4A604898-1A89-32D0-7964-55457B42E945}"/>
           </ac:spMkLst>
         </pc:spChg>
       </pc:sldChg>
@@ -367,7 +412,7 @@
           <a:p>
             <a:fld id="{F9D2AD6E-DEDD-49A0-A4BE-7A081A9112DA}" type="datetimeFigureOut">
               <a:rPr lang="en-US" smtClean="0"/>
-              <a:t>3/18/2026</a:t>
+              <a:t>4/14/2026</a:t>
             </a:fld>
             <a:endParaRPr lang="en-US"/>
           </a:p>
@@ -543,7 +588,7 @@
           </a:lstStyle>
           <a:p>
             <a:fld id="{2AF9C1A6-4321-41FA-B001-4140F0E2457F}" type="datetimeFigureOut">
-              <a:t>18.03.2026</a:t>
+              <a:t>14.04.2026</a:t>
             </a:fld>
             <a:endParaRPr lang="en-US"/>
           </a:p>
@@ -4349,6 +4394,309 @@
 </p:notes>
 </file>
 
+<file path=ppt/notesSlides/notesSlide6.xml><?xml version="1.0" encoding="utf-8"?>
+<p:notes xmlns:a="http://schemas.openxmlformats.org/drawingml/2006/main" xmlns:r="http://schemas.openxmlformats.org/officeDocument/2006/relationships" xmlns:p="http://schemas.openxmlformats.org/presentationml/2006/main">
+  <p:cSld>
+    <p:spTree>
+      <p:nvGrpSpPr>
+        <p:cNvPr id="1" name="">
+          <a:extLst>
+            <a:ext uri="{FF2B5EF4-FFF2-40B4-BE49-F238E27FC236}">
+              <a16:creationId xmlns:a16="http://schemas.microsoft.com/office/drawing/2014/main" id="{BB8DA34C-149A-57A8-DCCE-482263E209E7}"/>
+            </a:ext>
+          </a:extLst>
+        </p:cNvPr>
+        <p:cNvGrpSpPr/>
+        <p:nvPr/>
+      </p:nvGrpSpPr>
+      <p:grpSpPr>
+        <a:xfrm>
+          <a:off x="0" y="0"/>
+          <a:ext cx="0" cy="0"/>
+          <a:chOff x="0" y="0"/>
+          <a:chExt cx="0" cy="0"/>
+        </a:xfrm>
+      </p:grpSpPr>
+      <p:sp>
+        <p:nvSpPr>
+          <p:cNvPr id="2" name="Slide Image Placeholder 1">
+            <a:extLst>
+              <a:ext uri="{FF2B5EF4-FFF2-40B4-BE49-F238E27FC236}">
+                <a16:creationId xmlns:a16="http://schemas.microsoft.com/office/drawing/2014/main" id="{0212C817-AC27-CA90-93C2-204C3230EB4F}"/>
+              </a:ext>
+            </a:extLst>
+          </p:cNvPr>
+          <p:cNvSpPr>
+            <a:spLocks noGrp="1" noRot="1" noChangeAspect="1"/>
+          </p:cNvSpPr>
+          <p:nvPr>
+            <p:ph type="sldImg"/>
+          </p:nvPr>
+        </p:nvSpPr>
+        <p:spPr/>
+      </p:sp>
+      <p:sp>
+        <p:nvSpPr>
+          <p:cNvPr id="3" name="Notes Placeholder 2">
+            <a:extLst>
+              <a:ext uri="{FF2B5EF4-FFF2-40B4-BE49-F238E27FC236}">
+                <a16:creationId xmlns:a16="http://schemas.microsoft.com/office/drawing/2014/main" id="{73FC1774-130A-2B62-BCFA-16A9E5D06680}"/>
+              </a:ext>
+            </a:extLst>
+          </p:cNvPr>
+          <p:cNvSpPr>
+            <a:spLocks noGrp="1"/>
+          </p:cNvSpPr>
+          <p:nvPr>
+            <p:ph type="body" idx="1"/>
+          </p:nvPr>
+        </p:nvSpPr>
+        <p:spPr/>
+        <p:txBody>
+          <a:bodyPr/>
+          <a:lstStyle/>
+          <a:p>
+            <a:r>
+              <a:rPr lang="en-US" err="1">
+                <a:ea typeface="Calibri"/>
+                <a:cs typeface="Calibri"/>
+              </a:rPr>
+              <a:t>Milleks</a:t>
+            </a:r>
+            <a:r>
+              <a:rPr lang="en-US">
+                <a:ea typeface="Calibri"/>
+                <a:cs typeface="Calibri"/>
+              </a:rPr>
+              <a:t> </a:t>
+            </a:r>
+            <a:r>
+              <a:rPr lang="en-US" err="1">
+                <a:ea typeface="Calibri"/>
+                <a:cs typeface="Calibri"/>
+              </a:rPr>
+              <a:t>vajalik</a:t>
+            </a:r>
+            <a:r>
+              <a:rPr lang="en-US">
+                <a:ea typeface="Calibri"/>
+                <a:cs typeface="Calibri"/>
+              </a:rPr>
+              <a:t>? - Nii </a:t>
+            </a:r>
+            <a:r>
+              <a:rPr lang="en-US" err="1">
+                <a:ea typeface="Calibri"/>
+                <a:cs typeface="Calibri"/>
+              </a:rPr>
+              <a:t>enda</a:t>
+            </a:r>
+            <a:r>
+              <a:rPr lang="en-US">
+                <a:ea typeface="Calibri"/>
+                <a:cs typeface="Calibri"/>
+              </a:rPr>
+              <a:t> </a:t>
+            </a:r>
+            <a:r>
+              <a:rPr lang="en-US" err="1">
+                <a:ea typeface="Calibri"/>
+                <a:cs typeface="Calibri"/>
+              </a:rPr>
+              <a:t>kui</a:t>
+            </a:r>
+            <a:r>
+              <a:rPr lang="en-US">
+                <a:ea typeface="Calibri"/>
+                <a:cs typeface="Calibri"/>
+              </a:rPr>
+              <a:t> ka </a:t>
+            </a:r>
+            <a:r>
+              <a:rPr lang="en-US" err="1">
+                <a:ea typeface="Calibri"/>
+                <a:cs typeface="Calibri"/>
+              </a:rPr>
+              <a:t>kolleegide</a:t>
+            </a:r>
+            <a:r>
+              <a:rPr lang="en-US">
+                <a:ea typeface="Calibri"/>
+                <a:cs typeface="Calibri"/>
+              </a:rPr>
+              <a:t> </a:t>
+            </a:r>
+            <a:r>
+              <a:rPr lang="en-US" err="1">
+                <a:ea typeface="Calibri"/>
+                <a:cs typeface="Calibri"/>
+              </a:rPr>
+              <a:t>jaoks</a:t>
+            </a:r>
+            <a:r>
+              <a:rPr lang="en-US">
+                <a:ea typeface="Calibri"/>
+                <a:cs typeface="Calibri"/>
+              </a:rPr>
+              <a:t> </a:t>
+            </a:r>
+            <a:r>
+              <a:rPr lang="en-US" err="1">
+                <a:ea typeface="Calibri"/>
+                <a:cs typeface="Calibri"/>
+              </a:rPr>
+              <a:t>kirjeldamine</a:t>
+            </a:r>
+            <a:r>
+              <a:rPr lang="en-US">
+                <a:ea typeface="Calibri"/>
+                <a:cs typeface="Calibri"/>
+              </a:rPr>
+              <a:t>, </a:t>
+            </a:r>
+            <a:r>
+              <a:rPr lang="en-US" err="1">
+                <a:ea typeface="Calibri"/>
+                <a:cs typeface="Calibri"/>
+              </a:rPr>
+              <a:t>teada</a:t>
+            </a:r>
+            <a:r>
+              <a:rPr lang="en-US">
+                <a:ea typeface="Calibri"/>
+                <a:cs typeface="Calibri"/>
+              </a:rPr>
+              <a:t>, et </a:t>
+            </a:r>
+            <a:r>
+              <a:rPr lang="en-US" err="1">
+                <a:ea typeface="Calibri"/>
+                <a:cs typeface="Calibri"/>
+              </a:rPr>
+              <a:t>miks</a:t>
+            </a:r>
+            <a:r>
+              <a:rPr lang="en-US">
+                <a:ea typeface="Calibri"/>
+                <a:cs typeface="Calibri"/>
+              </a:rPr>
+              <a:t> ja </a:t>
+            </a:r>
+            <a:r>
+              <a:rPr lang="en-US" err="1">
+                <a:ea typeface="Calibri"/>
+                <a:cs typeface="Calibri"/>
+              </a:rPr>
+              <a:t>kuidas</a:t>
+            </a:r>
+            <a:r>
+              <a:rPr lang="en-US">
+                <a:ea typeface="Calibri"/>
+                <a:cs typeface="Calibri"/>
+              </a:rPr>
+              <a:t> </a:t>
+            </a:r>
+            <a:r>
+              <a:rPr lang="en-US" err="1">
+                <a:ea typeface="Calibri"/>
+                <a:cs typeface="Calibri"/>
+              </a:rPr>
+              <a:t>mingeid</a:t>
+            </a:r>
+            <a:r>
+              <a:rPr lang="en-US">
+                <a:ea typeface="Calibri"/>
+                <a:cs typeface="Calibri"/>
+              </a:rPr>
+              <a:t> </a:t>
+            </a:r>
+            <a:r>
+              <a:rPr lang="en-US" err="1">
+                <a:ea typeface="Calibri"/>
+                <a:cs typeface="Calibri"/>
+              </a:rPr>
+              <a:t>otsuseid</a:t>
+            </a:r>
+            <a:r>
+              <a:rPr lang="en-US">
+                <a:ea typeface="Calibri"/>
+                <a:cs typeface="Calibri"/>
+              </a:rPr>
+              <a:t> ja </a:t>
+            </a:r>
+            <a:r>
+              <a:rPr lang="en-US" err="1">
+                <a:ea typeface="Calibri"/>
+                <a:cs typeface="Calibri"/>
+              </a:rPr>
+              <a:t>muutusi</a:t>
+            </a:r>
+            <a:r>
+              <a:rPr lang="en-US">
+                <a:ea typeface="Calibri"/>
+                <a:cs typeface="Calibri"/>
+              </a:rPr>
+              <a:t> on </a:t>
+            </a:r>
+            <a:r>
+              <a:rPr lang="en-US" err="1">
+                <a:ea typeface="Calibri"/>
+                <a:cs typeface="Calibri"/>
+              </a:rPr>
+              <a:t>tehtud</a:t>
+            </a:r>
+            <a:r>
+              <a:rPr lang="en-US">
+                <a:ea typeface="Calibri"/>
+                <a:cs typeface="Calibri"/>
+              </a:rPr>
+              <a:t>.</a:t>
+            </a:r>
+          </a:p>
+        </p:txBody>
+      </p:sp>
+      <p:sp>
+        <p:nvSpPr>
+          <p:cNvPr id="4" name="Slide Number Placeholder 3">
+            <a:extLst>
+              <a:ext uri="{FF2B5EF4-FFF2-40B4-BE49-F238E27FC236}">
+                <a16:creationId xmlns:a16="http://schemas.microsoft.com/office/drawing/2014/main" id="{D12428F6-B692-59EB-721A-51F223C670DE}"/>
+              </a:ext>
+            </a:extLst>
+          </p:cNvPr>
+          <p:cNvSpPr>
+            <a:spLocks noGrp="1"/>
+          </p:cNvSpPr>
+          <p:nvPr>
+            <p:ph type="sldNum" sz="quarter" idx="5"/>
+          </p:nvPr>
+        </p:nvSpPr>
+        <p:spPr/>
+        <p:txBody>
+          <a:bodyPr/>
+          <a:lstStyle/>
+          <a:p>
+            <a:fld id="{46699514-027B-49BD-8B49-5054CA40ECF4}" type="slidenum">
+              <a:rPr lang="en-US"/>
+              <a:t>25</a:t>
+            </a:fld>
+            <a:endParaRPr lang="en-US"/>
+          </a:p>
+        </p:txBody>
+      </p:sp>
+    </p:spTree>
+    <p:extLst>
+      <p:ext uri="{BB962C8B-B14F-4D97-AF65-F5344CB8AC3E}">
+        <p14:creationId xmlns:p14="http://schemas.microsoft.com/office/powerpoint/2010/main" val="540613206"/>
+      </p:ext>
+    </p:extLst>
+  </p:cSld>
+  <p:clrMapOvr>
+    <a:masterClrMapping/>
+  </p:clrMapOvr>
+</p:notes>
+</file>
+
 <file path=ppt/slideLayouts/slideLayout1.xml><?xml version="1.0" encoding="utf-8"?>
 <p:sldLayout xmlns:a="http://schemas.openxmlformats.org/drawingml/2006/main" xmlns:r="http://schemas.openxmlformats.org/officeDocument/2006/relationships" xmlns:p="http://schemas.openxmlformats.org/presentationml/2006/main" preserve="1" userDrawn="1">
   <p:cSld name="Title_Large_Light">
@@ -4389,10 +4737,10 @@
           <p:nvPr userDrawn="1"/>
         </p:nvPicPr>
         <p:blipFill>
-          <a:blip r:embed="rId2">
+          <a:blip>
             <a:extLst>
               <a:ext uri="{96DAC541-7B7A-43D3-8B79-37D633B846F1}">
-                <asvg:svgBlip xmlns:asvg="http://schemas.microsoft.com/office/drawing/2016/SVG/main" r:embed="rId3"/>
+                <asvg:svgBlip xmlns:asvg="http://schemas.microsoft.com/office/drawing/2016/SVG/main" r:embed="rId2"/>
               </a:ext>
             </a:extLst>
           </a:blip>
@@ -13950,10 +14298,10 @@
             <a:ext cx="810000" cy="320400"/>
           </a:xfrm>
           <a:blipFill>
-            <a:blip r:embed="rId2">
+            <a:blip>
               <a:extLst>
                 <a:ext uri="{96DAC541-7B7A-43D3-8B79-37D633B846F1}">
-                  <asvg:svgBlip xmlns:asvg="http://schemas.microsoft.com/office/drawing/2016/SVG/main" r:embed="rId3"/>
+                  <asvg:svgBlip xmlns:asvg="http://schemas.microsoft.com/office/drawing/2016/SVG/main" r:embed="rId2"/>
                 </a:ext>
               </a:extLst>
             </a:blip>
@@ -15232,10 +15580,10 @@
             <a:ext cx="810000" cy="320400"/>
           </a:xfrm>
           <a:blipFill>
-            <a:blip r:embed="rId2">
+            <a:blip>
               <a:extLst>
                 <a:ext uri="{96DAC541-7B7A-43D3-8B79-37D633B846F1}">
-                  <asvg:svgBlip xmlns:asvg="http://schemas.microsoft.com/office/drawing/2016/SVG/main" r:embed="rId3"/>
+                  <asvg:svgBlip xmlns:asvg="http://schemas.microsoft.com/office/drawing/2016/SVG/main" r:embed="rId2"/>
                 </a:ext>
               </a:extLst>
             </a:blip>
@@ -15476,7 +15824,7 @@
           <a:p>
             <a:fld id="{DE840A40-73C8-4048-8140-49F5D65BB431}" type="datetimeFigureOut">
               <a:rPr lang="et-EE" smtClean="0"/>
-              <a:t>18.03.2026</a:t>
+              <a:t>14.04.2026</a:t>
             </a:fld>
             <a:endParaRPr lang="et-EE"/>
           </a:p>
@@ -15589,10 +15937,10 @@
           <p:nvPr userDrawn="1"/>
         </p:nvPicPr>
         <p:blipFill>
-          <a:blip r:embed="rId2">
+          <a:blip>
             <a:extLst>
               <a:ext uri="{96DAC541-7B7A-43D3-8B79-37D633B846F1}">
-                <asvg:svgBlip xmlns:asvg="http://schemas.microsoft.com/office/drawing/2016/SVG/main" r:embed="rId3"/>
+                <asvg:svgBlip xmlns:asvg="http://schemas.microsoft.com/office/drawing/2016/SVG/main" r:embed="rId2"/>
               </a:ext>
             </a:extLst>
           </a:blip>
@@ -22571,10 +22919,10 @@
             <a:ext cx="2302064" cy="927536"/>
           </a:xfrm>
           <a:blipFill>
-            <a:blip r:embed="rId2">
+            <a:blip>
               <a:extLst>
                 <a:ext uri="{96DAC541-7B7A-43D3-8B79-37D633B846F1}">
-                  <asvg:svgBlip xmlns:asvg="http://schemas.microsoft.com/office/drawing/2016/SVG/main" r:embed="rId3"/>
+                  <asvg:svgBlip xmlns:asvg="http://schemas.microsoft.com/office/drawing/2016/SVG/main" r:embed="rId2"/>
                 </a:ext>
               </a:extLst>
             </a:blip>
@@ -22757,10 +23105,10 @@
           <p:nvPr userDrawn="1"/>
         </p:nvPicPr>
         <p:blipFill>
-          <a:blip r:embed="rId2">
+          <a:blip>
             <a:extLst>
               <a:ext uri="{96DAC541-7B7A-43D3-8B79-37D633B846F1}">
-                <asvg:svgBlip xmlns:asvg="http://schemas.microsoft.com/office/drawing/2016/SVG/main" r:embed="rId3"/>
+                <asvg:svgBlip xmlns:asvg="http://schemas.microsoft.com/office/drawing/2016/SVG/main" r:embed="rId2"/>
               </a:ext>
             </a:extLst>
           </a:blip>
@@ -23491,10 +23839,10 @@
           <p:nvPr userDrawn="1"/>
         </p:nvPicPr>
         <p:blipFill>
-          <a:blip r:embed="rId2">
+          <a:blip>
             <a:extLst>
               <a:ext uri="{96DAC541-7B7A-43D3-8B79-37D633B846F1}">
-                <asvg:svgBlip xmlns:asvg="http://schemas.microsoft.com/office/drawing/2016/SVG/main" r:embed="rId3"/>
+                <asvg:svgBlip xmlns:asvg="http://schemas.microsoft.com/office/drawing/2016/SVG/main" r:embed="rId2"/>
               </a:ext>
             </a:extLst>
           </a:blip>
@@ -24280,10 +24628,10 @@
             <a:ext cx="810000" cy="320400"/>
           </a:xfrm>
           <a:blipFill>
-            <a:blip r:embed="rId2">
+            <a:blip>
               <a:extLst>
                 <a:ext uri="{96DAC541-7B7A-43D3-8B79-37D633B846F1}">
-                  <asvg:svgBlip xmlns:asvg="http://schemas.microsoft.com/office/drawing/2016/SVG/main" r:embed="rId3"/>
+                  <asvg:svgBlip xmlns:asvg="http://schemas.microsoft.com/office/drawing/2016/SVG/main" r:embed="rId2"/>
                 </a:ext>
               </a:extLst>
             </a:blip>
@@ -37221,7 +37569,7 @@
             <p:ph sz="quarter" idx="10"/>
             <p:extLst>
               <p:ext uri="{D42A27DB-BD31-4B8C-83A1-F6EECF244321}">
-                <p14:modId xmlns:p14="http://schemas.microsoft.com/office/powerpoint/2010/main" val="1587955701"/>
+                <p14:modId xmlns:p14="http://schemas.microsoft.com/office/powerpoint/2010/main" val="578815032"/>
               </p:ext>
             </p:extLst>
           </p:nvPr>
@@ -37701,25 +38049,22 @@
                           <a:effectLst/>
                           <a:latin typeface="Inter"/>
                         </a:rPr>
-                        <a:t>13:15 – 14:45 – Koolitus – </a:t>
+                        <a:t>13:15 – 15:15 – Koolitus – Kristina </a:t>
                       </a:r>
                       <a:r>
-                        <a:rPr lang="en-US" sz="2400" b="0" i="0" dirty="0" err="1">
+                        <a:rPr lang="et-EE" sz="2400" dirty="0"/>
+                        <a:t>Korobova </a:t>
+                      </a:r>
+                      <a:r>
+                        <a:rPr lang="en-US" sz="2400" b="0" i="0" dirty="0">
                           <a:solidFill>
                             <a:srgbClr val="121212"/>
                           </a:solidFill>
                           <a:effectLst/>
                           <a:latin typeface="Inter"/>
                         </a:rPr>
-                        <a:t>Külalisesineja</a:t>
+                        <a:t>(Bolt)</a:t>
                       </a:r>
-                      <a:endParaRPr lang="en-US" sz="2400" b="0" i="0" dirty="0">
-                        <a:solidFill>
-                          <a:srgbClr val="121212"/>
-                        </a:solidFill>
-                        <a:effectLst/>
-                        <a:latin typeface="Inter"/>
-                      </a:endParaRPr>
                     </a:p>
                   </a:txBody>
                   <a:tcPr marL="99060" marR="99060" marT="49530" marB="49530" anchor="ctr">
@@ -37789,7 +38134,7 @@
                           <a:effectLst/>
                           <a:latin typeface="Inter"/>
                         </a:rPr>
-                        <a:t>14:45 – 15:00 – Paus </a:t>
+                        <a:t>15:15 – 15:30 – Paus </a:t>
                       </a:r>
                       <a:endParaRPr lang="en-US" b="0" i="0" dirty="0">
                         <a:solidFill>
@@ -37867,7 +38212,7 @@
                           <a:effectLst/>
                           <a:latin typeface="Inter"/>
                         </a:rPr>
-                        <a:t>15:00 – 16:30 – Koolitus – </a:t>
+                        <a:t>15:30 – 16:30 – Koolitus – </a:t>
                       </a:r>
                       <a:r>
                         <a:rPr lang="en-US" sz="2400" b="0" i="0" dirty="0" err="1">
@@ -37877,7 +38222,47 @@
                           <a:effectLst/>
                           <a:latin typeface="Inter"/>
                         </a:rPr>
-                        <a:t>Külalisesineja</a:t>
+                        <a:t>Lõputööde</a:t>
+                      </a:r>
+                      <a:r>
+                        <a:rPr lang="en-US" sz="2400" b="0" i="0" dirty="0">
+                          <a:solidFill>
+                            <a:srgbClr val="121212"/>
+                          </a:solidFill>
+                          <a:effectLst/>
+                          <a:latin typeface="Inter"/>
+                        </a:rPr>
+                        <a:t> </a:t>
+                      </a:r>
+                      <a:r>
+                        <a:rPr lang="en-US" sz="2400" b="0" i="0" dirty="0" err="1">
+                          <a:solidFill>
+                            <a:srgbClr val="121212"/>
+                          </a:solidFill>
+                          <a:effectLst/>
+                          <a:latin typeface="Inter"/>
+                        </a:rPr>
+                        <a:t>projektidega</a:t>
+                      </a:r>
+                      <a:r>
+                        <a:rPr lang="en-US" sz="2400" b="0" i="0" dirty="0">
+                          <a:solidFill>
+                            <a:srgbClr val="121212"/>
+                          </a:solidFill>
+                          <a:effectLst/>
+                          <a:latin typeface="Inter"/>
+                        </a:rPr>
+                        <a:t> </a:t>
+                      </a:r>
+                      <a:r>
+                        <a:rPr lang="en-US" sz="2400" b="0" i="0" dirty="0" err="1">
+                          <a:solidFill>
+                            <a:srgbClr val="121212"/>
+                          </a:solidFill>
+                          <a:effectLst/>
+                          <a:latin typeface="Inter"/>
+                        </a:rPr>
+                        <a:t>alustamine</a:t>
                       </a:r>
                       <a:endParaRPr lang="en-US" sz="2400" b="0" i="0" dirty="0">
                         <a:solidFill>
@@ -38146,6 +38531,2460 @@
     <p:extLst>
       <p:ext uri="{BB962C8B-B14F-4D97-AF65-F5344CB8AC3E}">
         <p14:creationId xmlns:p14="http://schemas.microsoft.com/office/powerpoint/2010/main" val="1871966603"/>
+      </p:ext>
+    </p:extLst>
+  </p:cSld>
+  <p:clrMapOvr>
+    <a:masterClrMapping/>
+  </p:clrMapOvr>
+</p:sld>
+</file>
+
+<file path=ppt/slides/slide22.xml><?xml version="1.0" encoding="utf-8"?>
+<p:sld xmlns:a="http://schemas.openxmlformats.org/drawingml/2006/main" xmlns:r="http://schemas.openxmlformats.org/officeDocument/2006/relationships" xmlns:p="http://schemas.openxmlformats.org/presentationml/2006/main">
+  <p:cSld>
+    <p:spTree>
+      <p:nvGrpSpPr>
+        <p:cNvPr id="1" name="">
+          <a:extLst>
+            <a:ext uri="{FF2B5EF4-FFF2-40B4-BE49-F238E27FC236}">
+              <a16:creationId xmlns:a16="http://schemas.microsoft.com/office/drawing/2014/main" id="{A0AAEDE8-4802-6D47-FC8C-0D71004BFD9B}"/>
+            </a:ext>
+          </a:extLst>
+        </p:cNvPr>
+        <p:cNvGrpSpPr/>
+        <p:nvPr/>
+      </p:nvGrpSpPr>
+      <p:grpSpPr>
+        <a:xfrm>
+          <a:off x="0" y="0"/>
+          <a:ext cx="0" cy="0"/>
+          <a:chOff x="0" y="0"/>
+          <a:chExt cx="0" cy="0"/>
+        </a:xfrm>
+      </p:grpSpPr>
+      <p:sp>
+        <p:nvSpPr>
+          <p:cNvPr id="3" name="Content Placeholder 2">
+            <a:extLst>
+              <a:ext uri="{FF2B5EF4-FFF2-40B4-BE49-F238E27FC236}">
+                <a16:creationId xmlns:a16="http://schemas.microsoft.com/office/drawing/2014/main" id="{EDBF3FF4-C04B-25BA-46AE-8BE14DC04A1D}"/>
+              </a:ext>
+            </a:extLst>
+          </p:cNvPr>
+          <p:cNvSpPr>
+            <a:spLocks noGrp="1"/>
+          </p:cNvSpPr>
+          <p:nvPr>
+            <p:ph sz="quarter" idx="10"/>
+          </p:nvPr>
+        </p:nvSpPr>
+        <p:spPr/>
+        <p:txBody>
+          <a:bodyPr/>
+          <a:lstStyle/>
+          <a:p>
+            <a:pPr marL="0" indent="0">
+              <a:lnSpc>
+                <a:spcPct val="150000"/>
+              </a:lnSpc>
+              <a:buNone/>
+            </a:pPr>
+            <a:endParaRPr lang="en-US" sz="2800">
+              <a:ea typeface="Inter"/>
+            </a:endParaRPr>
+          </a:p>
+          <a:p>
+            <a:pPr marL="457200" lvl="1" indent="0">
+              <a:lnSpc>
+                <a:spcPct val="150000"/>
+              </a:lnSpc>
+              <a:buNone/>
+            </a:pPr>
+            <a:endParaRPr lang="en-US" sz="2000">
+              <a:ea typeface="Inter"/>
+            </a:endParaRPr>
+          </a:p>
+        </p:txBody>
+      </p:sp>
+      <p:sp>
+        <p:nvSpPr>
+          <p:cNvPr id="5" name="Title 4">
+            <a:extLst>
+              <a:ext uri="{FF2B5EF4-FFF2-40B4-BE49-F238E27FC236}">
+                <a16:creationId xmlns:a16="http://schemas.microsoft.com/office/drawing/2014/main" id="{F302593E-1699-CD76-2AB7-FB29D7F743E7}"/>
+              </a:ext>
+            </a:extLst>
+          </p:cNvPr>
+          <p:cNvSpPr>
+            <a:spLocks noGrp="1"/>
+          </p:cNvSpPr>
+          <p:nvPr>
+            <p:ph type="ctrTitle"/>
+          </p:nvPr>
+        </p:nvSpPr>
+        <p:spPr>
+          <a:xfrm>
+            <a:off x="3461336" y="2675333"/>
+            <a:ext cx="6575007" cy="357043"/>
+          </a:xfrm>
+        </p:spPr>
+        <p:txBody>
+          <a:bodyPr/>
+          <a:lstStyle/>
+          <a:p>
+            <a:r>
+              <a:rPr lang="en-US" dirty="0"/>
+              <a:t>Paus 15:15-15:30</a:t>
+            </a:r>
+          </a:p>
+        </p:txBody>
+      </p:sp>
+    </p:spTree>
+    <p:extLst>
+      <p:ext uri="{BB962C8B-B14F-4D97-AF65-F5344CB8AC3E}">
+        <p14:creationId xmlns:p14="http://schemas.microsoft.com/office/powerpoint/2010/main" val="3267241536"/>
+      </p:ext>
+    </p:extLst>
+  </p:cSld>
+  <p:clrMapOvr>
+    <a:masterClrMapping/>
+  </p:clrMapOvr>
+</p:sld>
+</file>
+
+<file path=ppt/slides/slide23.xml><?xml version="1.0" encoding="utf-8"?>
+<p:sld xmlns:a="http://schemas.openxmlformats.org/drawingml/2006/main" xmlns:r="http://schemas.openxmlformats.org/officeDocument/2006/relationships" xmlns:p="http://schemas.openxmlformats.org/presentationml/2006/main">
+  <p:cSld>
+    <p:spTree>
+      <p:nvGrpSpPr>
+        <p:cNvPr id="1" name="">
+          <a:extLst>
+            <a:ext uri="{FF2B5EF4-FFF2-40B4-BE49-F238E27FC236}">
+              <a16:creationId xmlns:a16="http://schemas.microsoft.com/office/drawing/2014/main" id="{15FF916F-3A2C-85BA-9906-09B4A79C0272}"/>
+            </a:ext>
+          </a:extLst>
+        </p:cNvPr>
+        <p:cNvGrpSpPr/>
+        <p:nvPr/>
+      </p:nvGrpSpPr>
+      <p:grpSpPr>
+        <a:xfrm>
+          <a:off x="0" y="0"/>
+          <a:ext cx="0" cy="0"/>
+          <a:chOff x="0" y="0"/>
+          <a:chExt cx="0" cy="0"/>
+        </a:xfrm>
+      </p:grpSpPr>
+      <p:sp>
+        <p:nvSpPr>
+          <p:cNvPr id="2" name="Title 1">
+            <a:extLst>
+              <a:ext uri="{FF2B5EF4-FFF2-40B4-BE49-F238E27FC236}">
+                <a16:creationId xmlns:a16="http://schemas.microsoft.com/office/drawing/2014/main" id="{D4725537-CB3E-C083-F8A7-F00B6AE12D6E}"/>
+              </a:ext>
+            </a:extLst>
+          </p:cNvPr>
+          <p:cNvSpPr>
+            <a:spLocks noGrp="1"/>
+          </p:cNvSpPr>
+          <p:nvPr>
+            <p:ph type="ctrTitle"/>
+          </p:nvPr>
+        </p:nvSpPr>
+        <p:spPr>
+          <a:xfrm>
+            <a:off x="614923" y="479570"/>
+            <a:ext cx="10044112" cy="357043"/>
+          </a:xfrm>
+        </p:spPr>
+        <p:txBody>
+          <a:bodyPr/>
+          <a:lstStyle/>
+          <a:p>
+            <a:r>
+              <a:rPr lang="en-US" b="1" err="1"/>
+              <a:t>Grupitöö</a:t>
+            </a:r>
+            <a:r>
+              <a:rPr lang="en-US" b="1"/>
+              <a:t> </a:t>
+            </a:r>
+            <a:r>
+              <a:rPr lang="en-US" b="1" err="1"/>
+              <a:t>osad</a:t>
+            </a:r>
+            <a:endParaRPr lang="en-US" err="1"/>
+          </a:p>
+        </p:txBody>
+      </p:sp>
+      <p:sp>
+        <p:nvSpPr>
+          <p:cNvPr id="3" name="Content Placeholder 2">
+            <a:extLst>
+              <a:ext uri="{FF2B5EF4-FFF2-40B4-BE49-F238E27FC236}">
+                <a16:creationId xmlns:a16="http://schemas.microsoft.com/office/drawing/2014/main" id="{721CFECB-31FC-C645-D35E-8C1758638C04}"/>
+              </a:ext>
+            </a:extLst>
+          </p:cNvPr>
+          <p:cNvSpPr>
+            <a:spLocks noGrp="1"/>
+          </p:cNvSpPr>
+          <p:nvPr>
+            <p:ph sz="quarter" idx="10"/>
+          </p:nvPr>
+        </p:nvSpPr>
+        <p:spPr/>
+        <p:txBody>
+          <a:bodyPr/>
+          <a:lstStyle/>
+          <a:p>
+            <a:pPr marL="457200" indent="-457200">
+              <a:lnSpc>
+                <a:spcPct val="150000"/>
+              </a:lnSpc>
+              <a:buAutoNum type="arabicPeriod"/>
+            </a:pPr>
+            <a:r>
+              <a:rPr lang="en-US" sz="2000" err="1">
+                <a:ea typeface="Inter"/>
+                <a:cs typeface="Noto Serif"/>
+              </a:rPr>
+              <a:t>Ettevõtte</a:t>
+            </a:r>
+            <a:r>
+              <a:rPr lang="en-US" sz="2000">
+                <a:ea typeface="Inter"/>
+                <a:cs typeface="Noto Serif"/>
+              </a:rPr>
+              <a:t> ja </a:t>
+            </a:r>
+            <a:r>
+              <a:rPr lang="en-US" sz="2000" err="1">
+                <a:ea typeface="Inter"/>
+                <a:cs typeface="Noto Serif"/>
+              </a:rPr>
+              <a:t>uurimisprobleemi</a:t>
+            </a:r>
+            <a:r>
+              <a:rPr lang="en-US" sz="2000">
+                <a:ea typeface="Inter"/>
+                <a:cs typeface="Noto Serif"/>
+              </a:rPr>
+              <a:t> </a:t>
+            </a:r>
+            <a:r>
+              <a:rPr lang="en-US" sz="2000" err="1">
+                <a:ea typeface="Inter"/>
+                <a:cs typeface="Noto Serif"/>
+              </a:rPr>
+              <a:t>tutvustus</a:t>
+            </a:r>
+            <a:endParaRPr lang="en-US" sz="2000" err="1">
+              <a:cs typeface="Noto Serif"/>
+            </a:endParaRPr>
+          </a:p>
+          <a:p>
+            <a:pPr marL="457200" indent="-457200">
+              <a:lnSpc>
+                <a:spcPct val="150000"/>
+              </a:lnSpc>
+              <a:buClr>
+                <a:srgbClr val="121212"/>
+              </a:buClr>
+              <a:buAutoNum type="arabicPeriod"/>
+            </a:pPr>
+            <a:r>
+              <a:rPr lang="en-US" sz="2000" err="1">
+                <a:ea typeface="Inter"/>
+                <a:cs typeface="Noto Serif"/>
+              </a:rPr>
+              <a:t>Uurimisplaan</a:t>
+            </a:r>
+            <a:endParaRPr lang="en-US" sz="2000" err="1">
+              <a:cs typeface="Noto Serif"/>
+            </a:endParaRPr>
+          </a:p>
+          <a:p>
+            <a:pPr marL="457200" indent="-457200">
+              <a:lnSpc>
+                <a:spcPct val="150000"/>
+              </a:lnSpc>
+              <a:buClr>
+                <a:srgbClr val="121212"/>
+              </a:buClr>
+              <a:buAutoNum type="arabicPeriod"/>
+            </a:pPr>
+            <a:r>
+              <a:rPr lang="en-US" sz="2000" err="1">
+                <a:ea typeface="Inter"/>
+                <a:cs typeface="Noto Serif"/>
+              </a:rPr>
+              <a:t>Andmekaitse</a:t>
+            </a:r>
+            <a:r>
+              <a:rPr lang="en-US" sz="2000">
+                <a:ea typeface="Inter"/>
+                <a:cs typeface="Noto Serif"/>
+              </a:rPr>
+              <a:t> </a:t>
+            </a:r>
+            <a:r>
+              <a:rPr lang="en-US" sz="2000" err="1">
+                <a:ea typeface="Inter"/>
+                <a:cs typeface="Noto Serif"/>
+              </a:rPr>
+              <a:t>kirjeldus</a:t>
+            </a:r>
+            <a:r>
+              <a:rPr lang="en-US" sz="2000">
+                <a:ea typeface="Inter"/>
+                <a:cs typeface="Noto Serif"/>
+              </a:rPr>
+              <a:t> – mis </a:t>
+            </a:r>
+            <a:r>
+              <a:rPr lang="en-US" sz="2000" err="1">
+                <a:ea typeface="Inter"/>
+                <a:cs typeface="Noto Serif"/>
+              </a:rPr>
+              <a:t>alustel</a:t>
+            </a:r>
+            <a:r>
+              <a:rPr lang="en-US" sz="2000">
+                <a:ea typeface="Inter"/>
+                <a:cs typeface="Noto Serif"/>
+              </a:rPr>
+              <a:t> </a:t>
+            </a:r>
+            <a:r>
+              <a:rPr lang="en-US" sz="2000" err="1">
+                <a:ea typeface="Inter"/>
+                <a:cs typeface="Noto Serif"/>
+              </a:rPr>
+              <a:t>andmeid</a:t>
+            </a:r>
+            <a:r>
+              <a:rPr lang="en-US" sz="2000">
+                <a:ea typeface="Inter"/>
+                <a:cs typeface="Noto Serif"/>
+              </a:rPr>
+              <a:t> </a:t>
+            </a:r>
+            <a:r>
+              <a:rPr lang="en-US" sz="2000" err="1">
+                <a:ea typeface="Inter"/>
+                <a:cs typeface="Noto Serif"/>
+              </a:rPr>
+              <a:t>töödeldakse</a:t>
+            </a:r>
+            <a:r>
+              <a:rPr lang="en-US" sz="2000">
+                <a:ea typeface="Inter"/>
+                <a:cs typeface="Noto Serif"/>
+              </a:rPr>
+              <a:t>?</a:t>
+            </a:r>
+            <a:endParaRPr lang="en-US" sz="2000">
+              <a:cs typeface="Noto Serif"/>
+            </a:endParaRPr>
+          </a:p>
+          <a:p>
+            <a:pPr marL="457200" indent="-457200">
+              <a:lnSpc>
+                <a:spcPct val="150000"/>
+              </a:lnSpc>
+              <a:buClr>
+                <a:srgbClr val="121212"/>
+              </a:buClr>
+              <a:buAutoNum type="arabicPeriod"/>
+            </a:pPr>
+            <a:r>
+              <a:rPr lang="en-US" sz="2000" err="1">
+                <a:ea typeface="Inter"/>
+                <a:cs typeface="Noto Serif"/>
+              </a:rPr>
+              <a:t>Ärisõnastik</a:t>
+            </a:r>
+            <a:r>
+              <a:rPr lang="en-US" sz="2000">
+                <a:ea typeface="Inter"/>
+                <a:cs typeface="Noto Serif"/>
+              </a:rPr>
+              <a:t>, </a:t>
+            </a:r>
+            <a:r>
+              <a:rPr lang="en-US" sz="2000" err="1">
+                <a:ea typeface="Inter"/>
+                <a:cs typeface="Noto Serif"/>
+              </a:rPr>
+              <a:t>andmemudel</a:t>
+            </a:r>
+            <a:r>
+              <a:rPr lang="en-US" sz="2000">
+                <a:ea typeface="Inter"/>
+                <a:cs typeface="Noto Serif"/>
+              </a:rPr>
+              <a:t>, </a:t>
+            </a:r>
+            <a:r>
+              <a:rPr lang="en-US" sz="2000" err="1">
+                <a:ea typeface="Inter"/>
+                <a:cs typeface="Noto Serif"/>
+              </a:rPr>
+              <a:t>andmesõnastik</a:t>
+            </a:r>
+            <a:endParaRPr lang="en-US" sz="2000" err="1">
+              <a:cs typeface="Noto Serif"/>
+            </a:endParaRPr>
+          </a:p>
+          <a:p>
+            <a:pPr marL="457200" indent="-457200">
+              <a:lnSpc>
+                <a:spcPct val="150000"/>
+              </a:lnSpc>
+              <a:buClr>
+                <a:srgbClr val="121212"/>
+              </a:buClr>
+              <a:buAutoNum type="arabicPeriod"/>
+            </a:pPr>
+            <a:r>
+              <a:rPr lang="en-US" sz="2000" err="1">
+                <a:ea typeface="Inter"/>
+                <a:cs typeface="Noto Serif"/>
+              </a:rPr>
+              <a:t>Andmevoog</a:t>
+            </a:r>
+            <a:endParaRPr lang="en-US" sz="2000" err="1">
+              <a:cs typeface="Noto Serif"/>
+            </a:endParaRPr>
+          </a:p>
+          <a:p>
+            <a:pPr marL="457200" indent="-457200">
+              <a:lnSpc>
+                <a:spcPct val="150000"/>
+              </a:lnSpc>
+              <a:buClr>
+                <a:srgbClr val="121212"/>
+              </a:buClr>
+              <a:buAutoNum type="arabicPeriod"/>
+            </a:pPr>
+            <a:r>
+              <a:rPr lang="en-US" sz="2000" err="1">
+                <a:ea typeface="Inter"/>
+                <a:cs typeface="Noto Serif"/>
+              </a:rPr>
+              <a:t>Näidisandmestiku</a:t>
+            </a:r>
+            <a:r>
+              <a:rPr lang="en-US" sz="2000">
+                <a:ea typeface="Inter"/>
+                <a:cs typeface="Noto Serif"/>
+              </a:rPr>
+              <a:t> </a:t>
+            </a:r>
+            <a:r>
+              <a:rPr lang="en-US" sz="2000" err="1">
+                <a:ea typeface="Inter"/>
+                <a:cs typeface="Noto Serif"/>
+              </a:rPr>
+              <a:t>loomine</a:t>
+            </a:r>
+            <a:endParaRPr lang="en-US" sz="2000" err="1">
+              <a:cs typeface="Noto Serif"/>
+            </a:endParaRPr>
+          </a:p>
+          <a:p>
+            <a:pPr marL="457200" indent="-457200">
+              <a:lnSpc>
+                <a:spcPct val="150000"/>
+              </a:lnSpc>
+              <a:buClr>
+                <a:srgbClr val="121212"/>
+              </a:buClr>
+              <a:buAutoNum type="arabicPeriod"/>
+            </a:pPr>
+            <a:r>
+              <a:rPr lang="en-US" sz="2000" err="1">
+                <a:ea typeface="Inter"/>
+                <a:cs typeface="Noto Serif"/>
+              </a:rPr>
+              <a:t>Andmete</a:t>
+            </a:r>
+            <a:r>
+              <a:rPr lang="en-US" sz="2000">
+                <a:ea typeface="Inter"/>
+                <a:cs typeface="Noto Serif"/>
+              </a:rPr>
+              <a:t> </a:t>
+            </a:r>
+            <a:r>
+              <a:rPr lang="en-US" sz="2000" err="1">
+                <a:ea typeface="Inter"/>
+                <a:cs typeface="Noto Serif"/>
+              </a:rPr>
+              <a:t>kvaliteedi</a:t>
+            </a:r>
+            <a:r>
+              <a:rPr lang="en-US" sz="2000">
+                <a:ea typeface="Inter"/>
+                <a:cs typeface="Noto Serif"/>
+              </a:rPr>
+              <a:t> </a:t>
+            </a:r>
+            <a:r>
+              <a:rPr lang="en-US" sz="2000" err="1">
+                <a:ea typeface="Inter"/>
+                <a:cs typeface="Noto Serif"/>
+              </a:rPr>
+              <a:t>kontroll</a:t>
+            </a:r>
+            <a:endParaRPr lang="en-US" sz="2000">
+              <a:cs typeface="Noto Serif"/>
+            </a:endParaRPr>
+          </a:p>
+          <a:p>
+            <a:pPr marL="457200" indent="-457200">
+              <a:lnSpc>
+                <a:spcPct val="150000"/>
+              </a:lnSpc>
+              <a:buClr>
+                <a:srgbClr val="121212"/>
+              </a:buClr>
+              <a:buAutoNum type="arabicPeriod"/>
+            </a:pPr>
+            <a:r>
+              <a:rPr lang="en-US" sz="2000" err="1">
+                <a:ea typeface="Inter"/>
+                <a:cs typeface="Noto Serif"/>
+              </a:rPr>
+              <a:t>Andmete</a:t>
+            </a:r>
+            <a:r>
+              <a:rPr lang="en-US" sz="2000">
+                <a:ea typeface="Inter"/>
+                <a:cs typeface="Noto Serif"/>
+              </a:rPr>
+              <a:t> </a:t>
+            </a:r>
+            <a:r>
+              <a:rPr lang="en-US" sz="2000" err="1">
+                <a:ea typeface="Inter"/>
+                <a:cs typeface="Noto Serif"/>
+              </a:rPr>
+              <a:t>eksploratiivne</a:t>
+            </a:r>
+            <a:r>
+              <a:rPr lang="en-US" sz="2000">
+                <a:ea typeface="Inter"/>
+                <a:cs typeface="Noto Serif"/>
+              </a:rPr>
+              <a:t> </a:t>
+            </a:r>
+            <a:r>
+              <a:rPr lang="en-US" sz="2000" err="1">
+                <a:ea typeface="Inter"/>
+                <a:cs typeface="Noto Serif"/>
+              </a:rPr>
+              <a:t>analüüs</a:t>
+            </a:r>
+            <a:endParaRPr lang="en-US" sz="2000">
+              <a:cs typeface="Noto Serif"/>
+            </a:endParaRPr>
+          </a:p>
+          <a:p>
+            <a:pPr marL="457200" indent="-457200">
+              <a:lnSpc>
+                <a:spcPct val="150000"/>
+              </a:lnSpc>
+              <a:buClr>
+                <a:srgbClr val="121212"/>
+              </a:buClr>
+              <a:buAutoNum type="arabicPeriod"/>
+            </a:pPr>
+            <a:r>
+              <a:rPr lang="en-US" sz="2000" err="1">
+                <a:ea typeface="Inter"/>
+                <a:cs typeface="Noto Serif"/>
+              </a:rPr>
+              <a:t>Andmete</a:t>
+            </a:r>
+            <a:r>
+              <a:rPr lang="en-US" sz="2000">
+                <a:ea typeface="Inter"/>
+                <a:cs typeface="Noto Serif"/>
+              </a:rPr>
+              <a:t> </a:t>
+            </a:r>
+            <a:r>
+              <a:rPr lang="en-US" sz="2000" err="1">
+                <a:ea typeface="Inter"/>
+                <a:cs typeface="Noto Serif"/>
+              </a:rPr>
+              <a:t>statistiline</a:t>
+            </a:r>
+            <a:r>
+              <a:rPr lang="en-US" sz="2000">
+                <a:ea typeface="Inter"/>
+                <a:cs typeface="Noto Serif"/>
+              </a:rPr>
+              <a:t> </a:t>
+            </a:r>
+            <a:r>
+              <a:rPr lang="en-US" sz="2000" err="1">
+                <a:ea typeface="Inter"/>
+                <a:cs typeface="Noto Serif"/>
+              </a:rPr>
+              <a:t>analüüs</a:t>
+            </a:r>
+            <a:endParaRPr lang="en-US" sz="2000" err="1">
+              <a:cs typeface="Noto Serif"/>
+            </a:endParaRPr>
+          </a:p>
+          <a:p>
+            <a:pPr marL="457200" indent="-457200">
+              <a:lnSpc>
+                <a:spcPct val="150000"/>
+              </a:lnSpc>
+              <a:buClr>
+                <a:srgbClr val="121212"/>
+              </a:buClr>
+              <a:buAutoNum type="arabicPeriod"/>
+            </a:pPr>
+            <a:r>
+              <a:rPr lang="en-US" sz="2000" err="1">
+                <a:ea typeface="Inter"/>
+                <a:cs typeface="Noto Serif"/>
+              </a:rPr>
+              <a:t>Kirjeldav</a:t>
+            </a:r>
+            <a:r>
+              <a:rPr lang="en-US" sz="2000">
+                <a:ea typeface="Inter"/>
+                <a:cs typeface="Noto Serif"/>
+              </a:rPr>
+              <a:t> </a:t>
+            </a:r>
+            <a:r>
+              <a:rPr lang="en-US" sz="2000" err="1">
+                <a:ea typeface="Inter"/>
+                <a:cs typeface="Noto Serif"/>
+              </a:rPr>
+              <a:t>raport</a:t>
+            </a:r>
+            <a:r>
+              <a:rPr lang="en-US" sz="2000">
+                <a:ea typeface="Inter"/>
+                <a:cs typeface="Noto Serif"/>
+              </a:rPr>
+              <a:t> / </a:t>
+            </a:r>
+            <a:r>
+              <a:rPr lang="en-US" sz="2000" err="1">
+                <a:ea typeface="Inter"/>
+                <a:cs typeface="Noto Serif"/>
+              </a:rPr>
+              <a:t>analüüs</a:t>
+            </a:r>
+            <a:endParaRPr lang="en-US" sz="2000" err="1">
+              <a:cs typeface="Noto Serif"/>
+            </a:endParaRPr>
+          </a:p>
+          <a:p>
+            <a:pPr marL="457200" indent="-457200">
+              <a:lnSpc>
+                <a:spcPct val="150000"/>
+              </a:lnSpc>
+              <a:buClr>
+                <a:srgbClr val="121212"/>
+              </a:buClr>
+              <a:buAutoNum type="arabicPeriod"/>
+            </a:pPr>
+            <a:r>
+              <a:rPr lang="en-US" sz="2000" err="1">
+                <a:ea typeface="Inter"/>
+                <a:cs typeface="Noto Serif"/>
+              </a:rPr>
+              <a:t>Andmelugu</a:t>
+            </a:r>
+            <a:r>
+              <a:rPr lang="en-US" sz="2000">
+                <a:ea typeface="Inter"/>
+                <a:cs typeface="Noto Serif"/>
+              </a:rPr>
+              <a:t>, </a:t>
+            </a:r>
+            <a:r>
+              <a:rPr lang="en-US" sz="2000" err="1">
+                <a:ea typeface="Inter"/>
+                <a:cs typeface="Noto Serif"/>
+              </a:rPr>
+              <a:t>järeldused</a:t>
+            </a:r>
+            <a:endParaRPr lang="en-US" sz="2000" err="1">
+              <a:cs typeface="Noto Serif"/>
+            </a:endParaRPr>
+          </a:p>
+          <a:p>
+            <a:pPr marL="342900" indent="-342900">
+              <a:lnSpc>
+                <a:spcPct val="150000"/>
+              </a:lnSpc>
+              <a:buClr>
+                <a:srgbClr val="121212"/>
+              </a:buClr>
+              <a:buFont typeface="Inter" panose="020B0502030000000004" pitchFamily="34" charset="0"/>
+              <a:buAutoNum type="arabicPeriod"/>
+            </a:pPr>
+            <a:endParaRPr lang="en-US" sz="2400">
+              <a:cs typeface="Noto Serif"/>
+            </a:endParaRPr>
+          </a:p>
+          <a:p>
+            <a:pPr marL="342900" indent="-342900">
+              <a:lnSpc>
+                <a:spcPct val="150000"/>
+              </a:lnSpc>
+              <a:buClr>
+                <a:srgbClr val="121212"/>
+              </a:buClr>
+              <a:buFont typeface="Inter" panose="020B0502030000000004" pitchFamily="34" charset="0"/>
+              <a:buAutoNum type="arabicPeriod"/>
+            </a:pPr>
+            <a:endParaRPr lang="en-US" sz="2400">
+              <a:cs typeface="Arial"/>
+            </a:endParaRPr>
+          </a:p>
+          <a:p>
+            <a:pPr marL="857250" lvl="1" indent="-342900">
+              <a:lnSpc>
+                <a:spcPct val="150000"/>
+              </a:lnSpc>
+              <a:buFont typeface="Arial,Sans-Serif" panose="020B0502030000000004" pitchFamily="34" charset="0"/>
+              <a:buChar char="o"/>
+            </a:pPr>
+            <a:endParaRPr lang="en-US" sz="2400">
+              <a:cs typeface="Arial"/>
+            </a:endParaRPr>
+          </a:p>
+          <a:p>
+            <a:pPr marL="342900" indent="-342900">
+              <a:lnSpc>
+                <a:spcPct val="150000"/>
+              </a:lnSpc>
+              <a:buAutoNum type="arabicPeriod"/>
+            </a:pPr>
+            <a:endParaRPr lang="en-US" sz="2400">
+              <a:cs typeface="Arial"/>
+            </a:endParaRPr>
+          </a:p>
+          <a:p>
+            <a:pPr marL="514350" indent="-514350">
+              <a:lnSpc>
+                <a:spcPct val="150000"/>
+              </a:lnSpc>
+              <a:buAutoNum type="arabicPeriod"/>
+            </a:pPr>
+            <a:endParaRPr lang="en-US" sz="2800">
+              <a:cs typeface="Arial"/>
+            </a:endParaRPr>
+          </a:p>
+          <a:p>
+            <a:pPr marL="0" indent="0">
+              <a:lnSpc>
+                <a:spcPct val="150000"/>
+              </a:lnSpc>
+              <a:buNone/>
+            </a:pPr>
+            <a:endParaRPr lang="en-US" sz="2800"/>
+          </a:p>
+        </p:txBody>
+      </p:sp>
+    </p:spTree>
+    <p:extLst>
+      <p:ext uri="{BB962C8B-B14F-4D97-AF65-F5344CB8AC3E}">
+        <p14:creationId xmlns:p14="http://schemas.microsoft.com/office/powerpoint/2010/main" val="645017635"/>
+      </p:ext>
+    </p:extLst>
+  </p:cSld>
+  <p:clrMapOvr>
+    <a:masterClrMapping/>
+  </p:clrMapOvr>
+</p:sld>
+</file>
+
+<file path=ppt/slides/slide24.xml><?xml version="1.0" encoding="utf-8"?>
+<p:sld xmlns:a="http://schemas.openxmlformats.org/drawingml/2006/main" xmlns:r="http://schemas.openxmlformats.org/officeDocument/2006/relationships" xmlns:p="http://schemas.openxmlformats.org/presentationml/2006/main">
+  <p:cSld>
+    <p:spTree>
+      <p:nvGrpSpPr>
+        <p:cNvPr id="1" name="">
+          <a:extLst>
+            <a:ext uri="{FF2B5EF4-FFF2-40B4-BE49-F238E27FC236}">
+              <a16:creationId xmlns:a16="http://schemas.microsoft.com/office/drawing/2014/main" id="{8ED024B8-E587-E3FE-2649-C69E942C14B4}"/>
+            </a:ext>
+          </a:extLst>
+        </p:cNvPr>
+        <p:cNvGrpSpPr/>
+        <p:nvPr/>
+      </p:nvGrpSpPr>
+      <p:grpSpPr>
+        <a:xfrm>
+          <a:off x="0" y="0"/>
+          <a:ext cx="0" cy="0"/>
+          <a:chOff x="0" y="0"/>
+          <a:chExt cx="0" cy="0"/>
+        </a:xfrm>
+      </p:grpSpPr>
+      <p:sp>
+        <p:nvSpPr>
+          <p:cNvPr id="2" name="Title 1">
+            <a:extLst>
+              <a:ext uri="{FF2B5EF4-FFF2-40B4-BE49-F238E27FC236}">
+                <a16:creationId xmlns:a16="http://schemas.microsoft.com/office/drawing/2014/main" id="{EF462382-376F-D403-218E-FAD6D454E702}"/>
+              </a:ext>
+            </a:extLst>
+          </p:cNvPr>
+          <p:cNvSpPr>
+            <a:spLocks noGrp="1"/>
+          </p:cNvSpPr>
+          <p:nvPr>
+            <p:ph type="ctrTitle"/>
+          </p:nvPr>
+        </p:nvSpPr>
+        <p:spPr>
+          <a:xfrm>
+            <a:off x="614923" y="479570"/>
+            <a:ext cx="10044112" cy="357043"/>
+          </a:xfrm>
+        </p:spPr>
+        <p:txBody>
+          <a:bodyPr/>
+          <a:lstStyle/>
+          <a:p>
+            <a:r>
+              <a:rPr lang="en-US" b="1" dirty="0" err="1"/>
+              <a:t>Grupitöö</a:t>
+            </a:r>
+            <a:r>
+              <a:rPr lang="en-US" b="1" dirty="0"/>
+              <a:t> - GitHub</a:t>
+            </a:r>
+            <a:endParaRPr lang="en-US" dirty="0"/>
+          </a:p>
+        </p:txBody>
+      </p:sp>
+      <p:sp>
+        <p:nvSpPr>
+          <p:cNvPr id="3" name="Content Placeholder 2">
+            <a:extLst>
+              <a:ext uri="{FF2B5EF4-FFF2-40B4-BE49-F238E27FC236}">
+                <a16:creationId xmlns:a16="http://schemas.microsoft.com/office/drawing/2014/main" id="{16CF7352-F93B-EE31-220C-F9E2EC9BDA2D}"/>
+              </a:ext>
+            </a:extLst>
+          </p:cNvPr>
+          <p:cNvSpPr>
+            <a:spLocks noGrp="1"/>
+          </p:cNvSpPr>
+          <p:nvPr>
+            <p:ph sz="quarter" idx="10"/>
+          </p:nvPr>
+        </p:nvSpPr>
+        <p:spPr/>
+        <p:txBody>
+          <a:bodyPr/>
+          <a:lstStyle/>
+          <a:p>
+            <a:pPr marL="342900" indent="-342900">
+              <a:lnSpc>
+                <a:spcPct val="150000"/>
+              </a:lnSpc>
+              <a:buFont typeface="Arial,Sans-Serif" panose="020B0502030000000004" pitchFamily="34" charset="0"/>
+              <a:buChar char="•"/>
+            </a:pPr>
+            <a:r>
+              <a:rPr lang="en-US" sz="2400" dirty="0" err="1">
+                <a:ea typeface="Inter"/>
+                <a:cs typeface="Noto Serif"/>
+              </a:rPr>
+              <a:t>Looge</a:t>
+            </a:r>
+            <a:r>
+              <a:rPr lang="en-US" sz="2400" dirty="0">
+                <a:ea typeface="Inter"/>
+                <a:cs typeface="Noto Serif"/>
+              </a:rPr>
+              <a:t> </a:t>
+            </a:r>
+            <a:r>
+              <a:rPr lang="en-US" sz="2400" dirty="0" err="1">
+                <a:ea typeface="Inter"/>
+                <a:cs typeface="Noto Serif"/>
+              </a:rPr>
+              <a:t>Githubi</a:t>
+            </a:r>
+            <a:r>
+              <a:rPr lang="en-US" sz="2400" dirty="0">
+                <a:ea typeface="Inter"/>
+                <a:cs typeface="Noto Serif"/>
+              </a:rPr>
+              <a:t> </a:t>
+            </a:r>
+            <a:r>
+              <a:rPr lang="en-US" sz="2400" dirty="0" err="1">
+                <a:ea typeface="Inter"/>
+                <a:cs typeface="Noto Serif"/>
+              </a:rPr>
+              <a:t>projekt</a:t>
+            </a:r>
+            <a:r>
+              <a:rPr lang="en-US" sz="2400" dirty="0">
+                <a:ea typeface="Inter"/>
+                <a:cs typeface="Noto Serif"/>
+              </a:rPr>
+              <a:t> – </a:t>
+            </a:r>
+            <a:r>
+              <a:rPr lang="en-US" sz="2400" dirty="0" err="1">
+                <a:ea typeface="Inter"/>
+                <a:cs typeface="Noto Serif"/>
+              </a:rPr>
+              <a:t>avalik</a:t>
+            </a:r>
+            <a:r>
+              <a:rPr lang="en-US" sz="2400" dirty="0">
+                <a:ea typeface="Inter"/>
+                <a:cs typeface="Noto Serif"/>
+              </a:rPr>
+              <a:t> repository </a:t>
+            </a:r>
+            <a:r>
+              <a:rPr lang="en-US" sz="2400" dirty="0" err="1">
+                <a:ea typeface="Inter"/>
+                <a:cs typeface="Noto Serif"/>
+              </a:rPr>
+              <a:t>mõne</a:t>
+            </a:r>
+            <a:r>
+              <a:rPr lang="en-US" sz="2400" dirty="0">
+                <a:ea typeface="Inter"/>
+                <a:cs typeface="Noto Serif"/>
+              </a:rPr>
+              <a:t> </a:t>
+            </a:r>
+            <a:r>
+              <a:rPr lang="en-US" sz="2400" dirty="0" err="1">
+                <a:ea typeface="Inter"/>
+                <a:cs typeface="Noto Serif"/>
+              </a:rPr>
+              <a:t>grupiliikme</a:t>
+            </a:r>
+            <a:r>
+              <a:rPr lang="en-US" sz="2400" dirty="0">
+                <a:ea typeface="Inter"/>
+                <a:cs typeface="Noto Serif"/>
+              </a:rPr>
+              <a:t> </a:t>
+            </a:r>
+            <a:r>
+              <a:rPr lang="en-US" sz="2400" dirty="0" err="1">
+                <a:ea typeface="Inter"/>
+                <a:cs typeface="Noto Serif"/>
+              </a:rPr>
+              <a:t>Githubis</a:t>
+            </a:r>
+            <a:endParaRPr lang="en-US" sz="2400" dirty="0">
+              <a:ea typeface="Inter"/>
+              <a:cs typeface="Noto Serif"/>
+            </a:endParaRPr>
+          </a:p>
+          <a:p>
+            <a:pPr marL="342900" indent="-342900">
+              <a:lnSpc>
+                <a:spcPct val="150000"/>
+              </a:lnSpc>
+              <a:buFont typeface="Arial,Sans-Serif" panose="020B0502030000000004" pitchFamily="34" charset="0"/>
+              <a:buChar char="•"/>
+            </a:pPr>
+            <a:r>
+              <a:rPr lang="en-US" sz="2400" dirty="0" err="1">
+                <a:ea typeface="Inter"/>
+                <a:cs typeface="Noto Serif"/>
+              </a:rPr>
+              <a:t>Lisage</a:t>
+            </a:r>
+            <a:r>
+              <a:rPr lang="en-US" sz="2400" dirty="0">
+                <a:ea typeface="Inter"/>
+                <a:cs typeface="Noto Serif"/>
+              </a:rPr>
+              <a:t> </a:t>
+            </a:r>
+            <a:r>
+              <a:rPr lang="en-US" sz="2400" dirty="0" err="1">
+                <a:ea typeface="Inter"/>
+                <a:cs typeface="Noto Serif"/>
+              </a:rPr>
+              <a:t>teised</a:t>
+            </a:r>
+            <a:r>
+              <a:rPr lang="en-US" sz="2400" dirty="0">
+                <a:ea typeface="Inter"/>
+                <a:cs typeface="Noto Serif"/>
+              </a:rPr>
+              <a:t> </a:t>
+            </a:r>
+            <a:r>
+              <a:rPr lang="en-US" sz="2400" dirty="0" err="1">
+                <a:ea typeface="Inter"/>
+                <a:cs typeface="Noto Serif"/>
+              </a:rPr>
+              <a:t>grupiliikmed</a:t>
+            </a:r>
+            <a:r>
+              <a:rPr lang="en-US" sz="2400" dirty="0">
+                <a:ea typeface="Inter"/>
+                <a:cs typeface="Noto Serif"/>
+              </a:rPr>
+              <a:t> Collaborators </a:t>
+            </a:r>
+            <a:r>
+              <a:rPr lang="en-US" sz="2400" dirty="0" err="1">
+                <a:ea typeface="Inter"/>
+                <a:cs typeface="Noto Serif"/>
+              </a:rPr>
+              <a:t>alla</a:t>
+            </a:r>
+            <a:endParaRPr lang="en-US" dirty="0">
+              <a:cs typeface="Noto Serif"/>
+            </a:endParaRPr>
+          </a:p>
+          <a:p>
+            <a:pPr marL="342900" indent="-342900">
+              <a:lnSpc>
+                <a:spcPct val="150000"/>
+              </a:lnSpc>
+              <a:buClr>
+                <a:srgbClr val="121212"/>
+              </a:buClr>
+              <a:buFont typeface="Arial,Sans-Serif" panose="020B0502030000000004" pitchFamily="34" charset="0"/>
+              <a:buChar char="•"/>
+            </a:pPr>
+            <a:r>
+              <a:rPr lang="en-US" sz="2400" dirty="0">
+                <a:ea typeface="Inter"/>
+                <a:cs typeface="Noto Serif"/>
+              </a:rPr>
+              <a:t>Clone repository </a:t>
+            </a:r>
+            <a:r>
+              <a:rPr lang="en-US" sz="2400" dirty="0" err="1">
+                <a:ea typeface="Inter"/>
+                <a:cs typeface="Noto Serif"/>
+              </a:rPr>
+              <a:t>oma</a:t>
+            </a:r>
+            <a:r>
+              <a:rPr lang="en-US" sz="2400" dirty="0">
+                <a:ea typeface="Inter"/>
+                <a:cs typeface="Noto Serif"/>
+              </a:rPr>
+              <a:t> </a:t>
+            </a:r>
+            <a:r>
+              <a:rPr lang="en-US" sz="2400" dirty="0" err="1">
+                <a:ea typeface="Inter"/>
+                <a:cs typeface="Noto Serif"/>
+              </a:rPr>
+              <a:t>kohalikku</a:t>
+            </a:r>
+            <a:r>
+              <a:rPr lang="en-US" sz="2400" dirty="0">
+                <a:ea typeface="Inter"/>
+                <a:cs typeface="Noto Serif"/>
+              </a:rPr>
+              <a:t> </a:t>
+            </a:r>
+            <a:r>
+              <a:rPr lang="en-US" sz="2400" dirty="0" err="1">
+                <a:ea typeface="Inter"/>
+                <a:cs typeface="Noto Serif"/>
+              </a:rPr>
+              <a:t>arvutisse</a:t>
+            </a:r>
+            <a:endParaRPr lang="en-US" sz="2400" dirty="0" err="1">
+              <a:cs typeface="Noto Serif"/>
+            </a:endParaRPr>
+          </a:p>
+          <a:p>
+            <a:pPr marL="342900" indent="-342900">
+              <a:lnSpc>
+                <a:spcPct val="150000"/>
+              </a:lnSpc>
+              <a:buClr>
+                <a:srgbClr val="121212"/>
+              </a:buClr>
+              <a:buFont typeface="Arial,Sans-Serif" panose="020B0502030000000004" pitchFamily="34" charset="0"/>
+              <a:buChar char="•"/>
+            </a:pPr>
+            <a:r>
+              <a:rPr lang="en-US" sz="2400" dirty="0" err="1">
+                <a:ea typeface="Inter"/>
+                <a:cs typeface="Noto Serif"/>
+              </a:rPr>
+              <a:t>Leppige</a:t>
+            </a:r>
+            <a:r>
+              <a:rPr lang="en-US" sz="2400" dirty="0">
+                <a:ea typeface="Inter"/>
+                <a:cs typeface="Noto Serif"/>
+              </a:rPr>
+              <a:t> </a:t>
+            </a:r>
+            <a:r>
+              <a:rPr lang="en-US" sz="2400" dirty="0" err="1">
+                <a:ea typeface="Inter"/>
+                <a:cs typeface="Noto Serif"/>
+              </a:rPr>
+              <a:t>kokku</a:t>
+            </a:r>
+            <a:r>
+              <a:rPr lang="en-US" sz="2400" dirty="0">
+                <a:ea typeface="Inter"/>
+                <a:cs typeface="Noto Serif"/>
+              </a:rPr>
+              <a:t>, </a:t>
+            </a:r>
+            <a:r>
+              <a:rPr lang="en-US" sz="2400" dirty="0" err="1">
+                <a:ea typeface="Inter"/>
+                <a:cs typeface="Noto Serif"/>
+              </a:rPr>
+              <a:t>kuidas</a:t>
+            </a:r>
+            <a:r>
+              <a:rPr lang="en-US" sz="2400" dirty="0">
+                <a:ea typeface="Inter"/>
+                <a:cs typeface="Noto Serif"/>
+              </a:rPr>
+              <a:t> </a:t>
+            </a:r>
+            <a:r>
+              <a:rPr lang="en-US" sz="2400" dirty="0" err="1">
+                <a:ea typeface="Inter"/>
+                <a:cs typeface="Noto Serif"/>
+              </a:rPr>
+              <a:t>muutusi</a:t>
+            </a:r>
+            <a:r>
+              <a:rPr lang="en-US" sz="2400" dirty="0">
+                <a:ea typeface="Inter"/>
+                <a:cs typeface="Noto Serif"/>
+              </a:rPr>
+              <a:t> </a:t>
+            </a:r>
+            <a:r>
+              <a:rPr lang="en-US" sz="2400" dirty="0" err="1">
+                <a:ea typeface="Inter"/>
+                <a:cs typeface="Noto Serif"/>
+              </a:rPr>
+              <a:t>üles</a:t>
+            </a:r>
+            <a:r>
+              <a:rPr lang="en-US" sz="2400" dirty="0">
+                <a:ea typeface="Inter"/>
+                <a:cs typeface="Noto Serif"/>
+              </a:rPr>
+              <a:t> </a:t>
+            </a:r>
+            <a:r>
+              <a:rPr lang="en-US" sz="2400" dirty="0" err="1">
+                <a:ea typeface="Inter"/>
+                <a:cs typeface="Noto Serif"/>
+              </a:rPr>
+              <a:t>laete</a:t>
+            </a:r>
+            <a:endParaRPr lang="en-US" sz="2400" dirty="0" err="1">
+              <a:cs typeface="Noto Serif"/>
+            </a:endParaRPr>
+          </a:p>
+          <a:p>
+            <a:pPr marL="857250" lvl="1" indent="-342900">
+              <a:lnSpc>
+                <a:spcPct val="150000"/>
+              </a:lnSpc>
+              <a:buFont typeface="Arial,Sans-Serif" panose="020B0502030000000004" pitchFamily="34" charset="0"/>
+              <a:buChar char="o"/>
+            </a:pPr>
+            <a:r>
+              <a:rPr lang="en-US" sz="2400" dirty="0" err="1">
+                <a:ea typeface="Inter"/>
+                <a:cs typeface="Noto Serif"/>
+              </a:rPr>
+              <a:t>Nt</a:t>
+            </a:r>
+            <a:r>
+              <a:rPr lang="en-US" sz="2400" dirty="0">
+                <a:ea typeface="Inter"/>
+                <a:cs typeface="Noto Serif"/>
+              </a:rPr>
+              <a:t> </a:t>
+            </a:r>
+            <a:r>
+              <a:rPr lang="en-US" sz="2400" dirty="0" err="1">
+                <a:ea typeface="Inter"/>
+                <a:cs typeface="Noto Serif"/>
+              </a:rPr>
+              <a:t>iga</a:t>
+            </a:r>
+            <a:r>
+              <a:rPr lang="en-US" sz="2400" dirty="0">
+                <a:ea typeface="Inter"/>
+                <a:cs typeface="Noto Serif"/>
+              </a:rPr>
+              <a:t> </a:t>
+            </a:r>
+            <a:r>
+              <a:rPr lang="en-US" sz="2400" dirty="0" err="1">
+                <a:ea typeface="Inter"/>
+                <a:cs typeface="Noto Serif"/>
+              </a:rPr>
+              <a:t>uue</a:t>
+            </a:r>
+            <a:r>
+              <a:rPr lang="en-US" sz="2400" dirty="0">
+                <a:ea typeface="Inter"/>
+                <a:cs typeface="Noto Serif"/>
+              </a:rPr>
+              <a:t> </a:t>
+            </a:r>
+            <a:r>
+              <a:rPr lang="en-US" sz="2400" dirty="0" err="1">
+                <a:ea typeface="Inter"/>
+                <a:cs typeface="Noto Serif"/>
+              </a:rPr>
+              <a:t>funktsionaalsuse</a:t>
+            </a:r>
+            <a:r>
+              <a:rPr lang="en-US" sz="2400" dirty="0">
+                <a:ea typeface="Inter"/>
+                <a:cs typeface="Noto Serif"/>
+              </a:rPr>
+              <a:t> </a:t>
+            </a:r>
+            <a:r>
+              <a:rPr lang="en-US" sz="2400" dirty="0" err="1">
+                <a:ea typeface="Inter"/>
+                <a:cs typeface="Noto Serif"/>
+              </a:rPr>
+              <a:t>jaoks</a:t>
+            </a:r>
+            <a:r>
+              <a:rPr lang="en-US" sz="2400" dirty="0">
+                <a:ea typeface="Inter"/>
+                <a:cs typeface="Noto Serif"/>
+              </a:rPr>
+              <a:t> </a:t>
+            </a:r>
+            <a:r>
+              <a:rPr lang="en-US" sz="2400" dirty="0" err="1">
+                <a:ea typeface="Inter"/>
+                <a:cs typeface="Noto Serif"/>
+              </a:rPr>
+              <a:t>eraldi</a:t>
+            </a:r>
+            <a:r>
+              <a:rPr lang="en-US" sz="2400" dirty="0">
+                <a:ea typeface="Inter"/>
+                <a:cs typeface="Noto Serif"/>
+              </a:rPr>
+              <a:t> "feature/..." Branch</a:t>
+            </a:r>
+            <a:endParaRPr lang="en-US" sz="2400" dirty="0">
+              <a:cs typeface="Noto Serif"/>
+            </a:endParaRPr>
+          </a:p>
+          <a:p>
+            <a:pPr marL="857250" lvl="1" indent="-342900">
+              <a:lnSpc>
+                <a:spcPct val="150000"/>
+              </a:lnSpc>
+              <a:buFont typeface="Arial,Sans-Serif" panose="020B0502030000000004" pitchFamily="34" charset="0"/>
+              <a:buChar char="o"/>
+            </a:pPr>
+            <a:r>
+              <a:rPr lang="en-US" sz="2400" dirty="0">
+                <a:ea typeface="Inter"/>
+                <a:cs typeface="Noto Serif"/>
+              </a:rPr>
+              <a:t>Kui </a:t>
+            </a:r>
+            <a:r>
+              <a:rPr lang="en-US" sz="2400" dirty="0" err="1">
+                <a:ea typeface="Inter"/>
+                <a:cs typeface="Noto Serif"/>
+              </a:rPr>
+              <a:t>iga</a:t>
+            </a:r>
+            <a:r>
+              <a:rPr lang="en-US" sz="2400" dirty="0">
+                <a:ea typeface="Inter"/>
+                <a:cs typeface="Noto Serif"/>
+              </a:rPr>
+              <a:t> </a:t>
+            </a:r>
+            <a:r>
+              <a:rPr lang="en-US" sz="2400" dirty="0" err="1">
+                <a:ea typeface="Inter"/>
+                <a:cs typeface="Noto Serif"/>
+              </a:rPr>
+              <a:t>funktsionaalsuse</a:t>
+            </a:r>
+            <a:r>
+              <a:rPr lang="en-US" sz="2400" dirty="0">
+                <a:ea typeface="Inter"/>
+                <a:cs typeface="Noto Serif"/>
+              </a:rPr>
+              <a:t> </a:t>
+            </a:r>
+            <a:r>
+              <a:rPr lang="en-US" sz="2400" dirty="0" err="1">
+                <a:ea typeface="Inter"/>
+                <a:cs typeface="Noto Serif"/>
+              </a:rPr>
+              <a:t>jaoks</a:t>
+            </a:r>
+            <a:r>
+              <a:rPr lang="en-US" sz="2400" dirty="0">
+                <a:ea typeface="Inter"/>
+                <a:cs typeface="Noto Serif"/>
+              </a:rPr>
+              <a:t> </a:t>
+            </a:r>
+            <a:r>
+              <a:rPr lang="en-US" sz="2400" dirty="0" err="1">
+                <a:ea typeface="Inter"/>
+                <a:cs typeface="Noto Serif"/>
+              </a:rPr>
+              <a:t>eraldi</a:t>
+            </a:r>
+            <a:r>
+              <a:rPr lang="en-US" sz="2400" dirty="0">
+                <a:ea typeface="Inter"/>
+                <a:cs typeface="Noto Serif"/>
+              </a:rPr>
+              <a:t> branch, </a:t>
+            </a:r>
+            <a:r>
+              <a:rPr lang="en-US" sz="2400" dirty="0" err="1">
+                <a:ea typeface="Inter"/>
+                <a:cs typeface="Noto Serif"/>
+              </a:rPr>
+              <a:t>siis</a:t>
+            </a:r>
+            <a:r>
+              <a:rPr lang="en-US" sz="2400" dirty="0">
+                <a:ea typeface="Inter"/>
+                <a:cs typeface="Noto Serif"/>
+              </a:rPr>
+              <a:t> </a:t>
+            </a:r>
+            <a:r>
+              <a:rPr lang="en-US" sz="2400" dirty="0" err="1">
+                <a:ea typeface="Inter"/>
+                <a:cs typeface="Noto Serif"/>
+              </a:rPr>
+              <a:t>pärast</a:t>
+            </a:r>
+            <a:r>
+              <a:rPr lang="en-US" sz="2400" dirty="0">
+                <a:ea typeface="Inter"/>
+                <a:cs typeface="Noto Serif"/>
+              </a:rPr>
+              <a:t> Pull </a:t>
+            </a:r>
+            <a:r>
+              <a:rPr lang="en-US" sz="2400" dirty="0" err="1">
+                <a:ea typeface="Inter"/>
+                <a:cs typeface="Noto Serif"/>
+              </a:rPr>
+              <a:t>Request'I</a:t>
+            </a:r>
+            <a:r>
+              <a:rPr lang="en-US" sz="2400" dirty="0">
+                <a:ea typeface="Inter"/>
+                <a:cs typeface="Noto Serif"/>
+              </a:rPr>
+              <a:t> </a:t>
+            </a:r>
+            <a:r>
+              <a:rPr lang="en-US" sz="2400" dirty="0" err="1">
+                <a:ea typeface="Inter"/>
+                <a:cs typeface="Noto Serif"/>
+              </a:rPr>
+              <a:t>kustutada</a:t>
+            </a:r>
+            <a:r>
+              <a:rPr lang="en-US" sz="2400" dirty="0">
+                <a:ea typeface="Inter"/>
+                <a:cs typeface="Noto Serif"/>
+              </a:rPr>
+              <a:t> feature branch</a:t>
+            </a:r>
+            <a:endParaRPr lang="en-US" sz="2400" dirty="0">
+              <a:cs typeface="Noto Serif"/>
+            </a:endParaRPr>
+          </a:p>
+          <a:p>
+            <a:pPr marL="342900" indent="-342900">
+              <a:lnSpc>
+                <a:spcPct val="150000"/>
+              </a:lnSpc>
+              <a:buClr>
+                <a:srgbClr val="121212"/>
+              </a:buClr>
+              <a:buFont typeface="Arial,Sans-Serif" panose="020B0502030000000004" pitchFamily="34" charset="0"/>
+              <a:buChar char="•"/>
+            </a:pPr>
+            <a:endParaRPr lang="en-US" sz="2400" dirty="0">
+              <a:cs typeface="Noto Serif"/>
+            </a:endParaRPr>
+          </a:p>
+          <a:p>
+            <a:pPr marL="342900" indent="-342900">
+              <a:lnSpc>
+                <a:spcPct val="150000"/>
+              </a:lnSpc>
+              <a:buClr>
+                <a:srgbClr val="121212"/>
+              </a:buClr>
+              <a:buFont typeface="Arial,Sans-Serif" panose="020B0502030000000004" pitchFamily="34" charset="0"/>
+              <a:buChar char="•"/>
+            </a:pPr>
+            <a:endParaRPr lang="en-US" sz="2400" dirty="0">
+              <a:cs typeface="Arial"/>
+            </a:endParaRPr>
+          </a:p>
+          <a:p>
+            <a:pPr marL="857250" lvl="1" indent="-342900">
+              <a:lnSpc>
+                <a:spcPct val="150000"/>
+              </a:lnSpc>
+              <a:buFont typeface="Arial,Sans-Serif" panose="020B0502030000000004" pitchFamily="34" charset="0"/>
+              <a:buChar char="o"/>
+            </a:pPr>
+            <a:endParaRPr lang="en-US" sz="2400" dirty="0">
+              <a:cs typeface="Arial"/>
+            </a:endParaRPr>
+          </a:p>
+          <a:p>
+            <a:pPr marL="342900" indent="-342900">
+              <a:lnSpc>
+                <a:spcPct val="150000"/>
+              </a:lnSpc>
+              <a:buFont typeface="Arial,Sans-Serif" panose="020B0502030000000004" pitchFamily="34" charset="0"/>
+              <a:buChar char="•"/>
+            </a:pPr>
+            <a:endParaRPr lang="en-US" sz="2400" dirty="0">
+              <a:cs typeface="Arial"/>
+            </a:endParaRPr>
+          </a:p>
+          <a:p>
+            <a:pPr marL="514350" indent="-514350">
+              <a:lnSpc>
+                <a:spcPct val="150000"/>
+              </a:lnSpc>
+            </a:pPr>
+            <a:endParaRPr lang="en-US" sz="2800" dirty="0">
+              <a:cs typeface="Arial"/>
+            </a:endParaRPr>
+          </a:p>
+          <a:p>
+            <a:pPr marL="0" indent="0">
+              <a:lnSpc>
+                <a:spcPct val="150000"/>
+              </a:lnSpc>
+              <a:buNone/>
+            </a:pPr>
+            <a:endParaRPr lang="en-US" sz="2800" dirty="0"/>
+          </a:p>
+        </p:txBody>
+      </p:sp>
+    </p:spTree>
+    <p:extLst>
+      <p:ext uri="{BB962C8B-B14F-4D97-AF65-F5344CB8AC3E}">
+        <p14:creationId xmlns:p14="http://schemas.microsoft.com/office/powerpoint/2010/main" val="1674079011"/>
+      </p:ext>
+    </p:extLst>
+  </p:cSld>
+  <p:clrMapOvr>
+    <a:masterClrMapping/>
+  </p:clrMapOvr>
+</p:sld>
+</file>
+
+<file path=ppt/slides/slide25.xml><?xml version="1.0" encoding="utf-8"?>
+<p:sld xmlns:a="http://schemas.openxmlformats.org/drawingml/2006/main" xmlns:r="http://schemas.openxmlformats.org/officeDocument/2006/relationships" xmlns:p="http://schemas.openxmlformats.org/presentationml/2006/main">
+  <p:cSld>
+    <p:spTree>
+      <p:nvGrpSpPr>
+        <p:cNvPr id="1" name="">
+          <a:extLst>
+            <a:ext uri="{FF2B5EF4-FFF2-40B4-BE49-F238E27FC236}">
+              <a16:creationId xmlns:a16="http://schemas.microsoft.com/office/drawing/2014/main" id="{AA80EE9B-3020-A266-14D5-3A10FD23920C}"/>
+            </a:ext>
+          </a:extLst>
+        </p:cNvPr>
+        <p:cNvGrpSpPr/>
+        <p:nvPr/>
+      </p:nvGrpSpPr>
+      <p:grpSpPr>
+        <a:xfrm>
+          <a:off x="0" y="0"/>
+          <a:ext cx="0" cy="0"/>
+          <a:chOff x="0" y="0"/>
+          <a:chExt cx="0" cy="0"/>
+        </a:xfrm>
+      </p:grpSpPr>
+      <p:sp>
+        <p:nvSpPr>
+          <p:cNvPr id="2" name="Title 1">
+            <a:extLst>
+              <a:ext uri="{FF2B5EF4-FFF2-40B4-BE49-F238E27FC236}">
+                <a16:creationId xmlns:a16="http://schemas.microsoft.com/office/drawing/2014/main" id="{09CB3CE6-A314-B235-7804-1DB6617CEBB9}"/>
+              </a:ext>
+            </a:extLst>
+          </p:cNvPr>
+          <p:cNvSpPr>
+            <a:spLocks noGrp="1"/>
+          </p:cNvSpPr>
+          <p:nvPr>
+            <p:ph type="ctrTitle"/>
+          </p:nvPr>
+        </p:nvSpPr>
+        <p:spPr/>
+        <p:txBody>
+          <a:bodyPr/>
+          <a:lstStyle/>
+          <a:p>
+            <a:r>
+              <a:rPr lang="en-US" dirty="0" err="1"/>
+              <a:t>Versioonihaldus</a:t>
+            </a:r>
+            <a:r>
+              <a:rPr lang="en-US" dirty="0"/>
+              <a:t> – </a:t>
+            </a:r>
+            <a:r>
+              <a:rPr lang="en-US" dirty="0" err="1"/>
+              <a:t>muutuste</a:t>
+            </a:r>
+            <a:r>
+              <a:rPr lang="en-US" dirty="0"/>
+              <a:t> </a:t>
+            </a:r>
+            <a:r>
+              <a:rPr lang="en-US" dirty="0" err="1"/>
+              <a:t>üles</a:t>
+            </a:r>
+            <a:r>
+              <a:rPr lang="en-US" dirty="0"/>
+              <a:t> </a:t>
+            </a:r>
+            <a:r>
+              <a:rPr lang="en-US" dirty="0" err="1"/>
+              <a:t>laadimine</a:t>
+            </a:r>
+          </a:p>
+        </p:txBody>
+      </p:sp>
+      <p:sp>
+        <p:nvSpPr>
+          <p:cNvPr id="3" name="Content Placeholder 2">
+            <a:extLst>
+              <a:ext uri="{FF2B5EF4-FFF2-40B4-BE49-F238E27FC236}">
+                <a16:creationId xmlns:a16="http://schemas.microsoft.com/office/drawing/2014/main" id="{CF773C7E-895D-19CD-768D-5D677901F556}"/>
+              </a:ext>
+            </a:extLst>
+          </p:cNvPr>
+          <p:cNvSpPr>
+            <a:spLocks noGrp="1"/>
+          </p:cNvSpPr>
+          <p:nvPr>
+            <p:ph sz="quarter" idx="10"/>
+          </p:nvPr>
+        </p:nvSpPr>
+        <p:spPr/>
+        <p:txBody>
+          <a:bodyPr/>
+          <a:lstStyle/>
+          <a:p>
+            <a:pPr marL="457200" indent="-457200">
+              <a:lnSpc>
+                <a:spcPct val="150000"/>
+              </a:lnSpc>
+              <a:buClr>
+                <a:srgbClr val="121212"/>
+              </a:buClr>
+              <a:buAutoNum type="arabicPeriod"/>
+            </a:pPr>
+            <a:r>
+              <a:rPr lang="en-US" sz="2400" dirty="0">
+                <a:ea typeface="Inter"/>
+              </a:rPr>
+              <a:t>Tee </a:t>
+            </a:r>
+            <a:r>
+              <a:rPr lang="en-US" sz="2400" dirty="0" err="1">
+                <a:ea typeface="Inter"/>
+              </a:rPr>
+              <a:t>muutused</a:t>
+            </a:r>
+            <a:r>
+              <a:rPr lang="en-US" sz="2400" dirty="0">
+                <a:ea typeface="Inter"/>
+              </a:rPr>
+              <a:t> </a:t>
+            </a:r>
+            <a:r>
+              <a:rPr lang="en-US" sz="2400" dirty="0" err="1">
+                <a:ea typeface="Inter"/>
+              </a:rPr>
+              <a:t>kohalikus</a:t>
+            </a:r>
+            <a:r>
+              <a:rPr lang="en-US" sz="2400" dirty="0">
+                <a:ea typeface="Inter"/>
+              </a:rPr>
+              <a:t> </a:t>
+            </a:r>
+            <a:r>
+              <a:rPr lang="en-US" sz="2400" dirty="0" err="1">
+                <a:ea typeface="Inter"/>
+              </a:rPr>
+              <a:t>kaustas</a:t>
+            </a:r>
+            <a:endParaRPr lang="en-US" sz="2400" dirty="0">
+              <a:ea typeface="Inter"/>
+            </a:endParaRPr>
+          </a:p>
+          <a:p>
+            <a:pPr marL="400050" indent="-457200">
+              <a:lnSpc>
+                <a:spcPct val="150000"/>
+              </a:lnSpc>
+              <a:buClr>
+                <a:srgbClr val="121212"/>
+              </a:buClr>
+              <a:buAutoNum type="arabicPeriod"/>
+            </a:pPr>
+            <a:r>
+              <a:rPr lang="en-US" sz="2400" dirty="0">
+                <a:ea typeface="Inter"/>
+              </a:rPr>
+              <a:t>Vali </a:t>
+            </a:r>
+            <a:r>
+              <a:rPr lang="en-US" sz="2400" dirty="0" err="1">
+                <a:ea typeface="Inter"/>
+              </a:rPr>
+              <a:t>enda</a:t>
+            </a:r>
+            <a:r>
+              <a:rPr lang="en-US" sz="2400" dirty="0">
+                <a:ea typeface="Inter"/>
+              </a:rPr>
+              <a:t> Branch</a:t>
+            </a:r>
+            <a:endParaRPr lang="en-US" dirty="0"/>
+          </a:p>
+          <a:p>
+            <a:pPr marL="400050" indent="-457200">
+              <a:lnSpc>
+                <a:spcPct val="150000"/>
+              </a:lnSpc>
+              <a:buClr>
+                <a:srgbClr val="121212"/>
+              </a:buClr>
+              <a:buAutoNum type="arabicPeriod"/>
+            </a:pPr>
+            <a:r>
+              <a:rPr lang="en-US" sz="2400" dirty="0">
+                <a:ea typeface="Inter"/>
+              </a:rPr>
+              <a:t>VS Code: Pull from main</a:t>
+            </a:r>
+            <a:endParaRPr lang="en-US" dirty="0"/>
+          </a:p>
+          <a:p>
+            <a:pPr marL="400050" indent="-457200">
+              <a:lnSpc>
+                <a:spcPct val="150000"/>
+              </a:lnSpc>
+              <a:buClr>
+                <a:srgbClr val="121212"/>
+              </a:buClr>
+              <a:buAutoNum type="arabicPeriod"/>
+            </a:pPr>
+            <a:r>
+              <a:rPr lang="en-US" sz="2400" dirty="0">
+                <a:ea typeface="Inter"/>
+              </a:rPr>
+              <a:t>VS Code: Lisa </a:t>
+            </a:r>
+            <a:r>
+              <a:rPr lang="en-US" sz="2400" err="1">
+                <a:ea typeface="Inter"/>
+              </a:rPr>
+              <a:t>kommentaar</a:t>
+            </a:r>
+            <a:r>
+              <a:rPr lang="en-US" sz="2400" dirty="0">
+                <a:ea typeface="Inter"/>
+              </a:rPr>
+              <a:t> ja Commit</a:t>
+            </a:r>
+            <a:endParaRPr lang="en-US" sz="2400" dirty="0"/>
+          </a:p>
+          <a:p>
+            <a:pPr marL="400050" indent="-457200">
+              <a:lnSpc>
+                <a:spcPct val="150000"/>
+              </a:lnSpc>
+              <a:buClr>
+                <a:srgbClr val="121212"/>
+              </a:buClr>
+              <a:buAutoNum type="arabicPeriod"/>
+            </a:pPr>
+            <a:r>
+              <a:rPr lang="en-US" sz="2400" dirty="0">
+                <a:ea typeface="Inter"/>
+              </a:rPr>
+              <a:t>VS Code: Sync Changes</a:t>
+            </a:r>
+            <a:endParaRPr lang="en-US" sz="2400" dirty="0"/>
+          </a:p>
+          <a:p>
+            <a:pPr marL="400050" indent="-457200">
+              <a:lnSpc>
+                <a:spcPct val="150000"/>
+              </a:lnSpc>
+              <a:buClr>
+                <a:srgbClr val="121212"/>
+              </a:buClr>
+              <a:buAutoNum type="arabicPeriod"/>
+            </a:pPr>
+            <a:r>
+              <a:rPr lang="en-US" sz="2400" err="1">
+                <a:ea typeface="Inter"/>
+              </a:rPr>
+              <a:t>Github</a:t>
+            </a:r>
+            <a:r>
+              <a:rPr lang="en-US" sz="2400" dirty="0">
+                <a:ea typeface="Inter"/>
+              </a:rPr>
+              <a:t>: Vali </a:t>
+            </a:r>
+            <a:r>
+              <a:rPr lang="en-US" sz="2400" err="1">
+                <a:ea typeface="Inter"/>
+              </a:rPr>
+              <a:t>enda</a:t>
+            </a:r>
+            <a:r>
+              <a:rPr lang="en-US" sz="2400" dirty="0">
+                <a:ea typeface="Inter"/>
+              </a:rPr>
+              <a:t> Branch</a:t>
+            </a:r>
+          </a:p>
+          <a:p>
+            <a:pPr marL="400050" indent="-457200">
+              <a:lnSpc>
+                <a:spcPct val="150000"/>
+              </a:lnSpc>
+              <a:buClr>
+                <a:srgbClr val="121212"/>
+              </a:buClr>
+              <a:buAutoNum type="arabicPeriod"/>
+            </a:pPr>
+            <a:r>
+              <a:rPr lang="en-US" sz="2400" dirty="0" err="1">
+                <a:ea typeface="Inter"/>
+              </a:rPr>
+              <a:t>Github</a:t>
+            </a:r>
+            <a:r>
+              <a:rPr lang="en-US" sz="2400" dirty="0">
+                <a:ea typeface="Inter"/>
+              </a:rPr>
+              <a:t>: </a:t>
+            </a:r>
+            <a:r>
+              <a:rPr lang="en-US" sz="2400" dirty="0" err="1">
+                <a:ea typeface="Inter"/>
+              </a:rPr>
+              <a:t>Kliki</a:t>
+            </a:r>
+            <a:r>
+              <a:rPr lang="en-US" sz="2400" dirty="0">
+                <a:ea typeface="Inter"/>
+              </a:rPr>
+              <a:t> "This branch is 1 commit ahead"</a:t>
+            </a:r>
+          </a:p>
+          <a:p>
+            <a:pPr marL="400050" indent="-457200">
+              <a:lnSpc>
+                <a:spcPct val="150000"/>
+              </a:lnSpc>
+              <a:buClr>
+                <a:srgbClr val="121212"/>
+              </a:buClr>
+              <a:buAutoNum type="arabicPeriod"/>
+            </a:pPr>
+            <a:r>
+              <a:rPr lang="en-US" sz="2400" dirty="0">
+                <a:ea typeface="Inter"/>
+              </a:rPr>
+              <a:t>GitHub: Create Pull Request</a:t>
+            </a:r>
+            <a:endParaRPr lang="en-US" sz="2400" dirty="0"/>
+          </a:p>
+          <a:p>
+            <a:pPr marL="400050" indent="-457200">
+              <a:lnSpc>
+                <a:spcPct val="150000"/>
+              </a:lnSpc>
+              <a:buClr>
+                <a:srgbClr val="121212"/>
+              </a:buClr>
+              <a:buAutoNum type="arabicPeriod"/>
+            </a:pPr>
+            <a:r>
+              <a:rPr lang="en-US" sz="2400" dirty="0">
+                <a:ea typeface="Inter"/>
+              </a:rPr>
+              <a:t>GitHub: Merge Pull Request</a:t>
+            </a:r>
+            <a:endParaRPr lang="en-US" sz="2400" dirty="0"/>
+          </a:p>
+          <a:p>
+            <a:pPr>
+              <a:buClr>
+                <a:srgbClr val="121212"/>
+              </a:buClr>
+              <a:buAutoNum type="arabicPeriod"/>
+            </a:pPr>
+            <a:endParaRPr lang="en-US"/>
+          </a:p>
+        </p:txBody>
+      </p:sp>
+    </p:spTree>
+    <p:extLst>
+      <p:ext uri="{BB962C8B-B14F-4D97-AF65-F5344CB8AC3E}">
+        <p14:creationId xmlns:p14="http://schemas.microsoft.com/office/powerpoint/2010/main" val="1694942831"/>
+      </p:ext>
+    </p:extLst>
+  </p:cSld>
+  <p:clrMapOvr>
+    <a:masterClrMapping/>
+  </p:clrMapOvr>
+  <p:timing>
+    <p:tnLst>
+      <p:par>
+        <p:cTn id="1" dur="indefinite" restart="never" nodeType="tmRoot">
+          <p:childTnLst>
+            <p:seq concurrent="1" nextAc="seek">
+              <p:cTn id="2" dur="indefinite" nodeType="mainSeq">
+                <p:childTnLst>
+                  <p:par>
+                    <p:cTn id="3" fill="hold">
+                      <p:stCondLst>
+                        <p:cond delay="indefinite"/>
+                      </p:stCondLst>
+                      <p:childTnLst>
+                        <p:par>
+                          <p:cTn id="4" fill="hold">
+                            <p:stCondLst>
+                              <p:cond delay="0"/>
+                            </p:stCondLst>
+                            <p:childTnLst>
+                              <p:par>
+                                <p:cTn id="5" presetID="1" presetClass="entr" presetSubtype="0" fill="hold" grpId="0" nodeType="clickEffect">
+                                  <p:stCondLst>
+                                    <p:cond delay="0"/>
+                                  </p:stCondLst>
+                                  <p:childTnLst>
+                                    <p:set>
+                                      <p:cBhvr>
+                                        <p:cTn id="6" dur="1" fill="hold">
+                                          <p:stCondLst>
+                                            <p:cond delay="0"/>
+                                          </p:stCondLst>
+                                        </p:cTn>
+                                        <p:tgtEl>
+                                          <p:spTgt spid="3">
+                                            <p:txEl>
+                                              <p:pRg st="0" end="0"/>
+                                            </p:txEl>
+                                          </p:spTgt>
+                                        </p:tgtEl>
+                                        <p:attrNameLst>
+                                          <p:attrName>style.visibility</p:attrName>
+                                        </p:attrNameLst>
+                                      </p:cBhvr>
+                                      <p:to>
+                                        <p:strVal val="visible"/>
+                                      </p:to>
+                                    </p:set>
+                                  </p:childTnLst>
+                                </p:cTn>
+                              </p:par>
+                            </p:childTnLst>
+                          </p:cTn>
+                        </p:par>
+                      </p:childTnLst>
+                    </p:cTn>
+                  </p:par>
+                  <p:par>
+                    <p:cTn id="7" fill="hold">
+                      <p:stCondLst>
+                        <p:cond delay="indefinite"/>
+                      </p:stCondLst>
+                      <p:childTnLst>
+                        <p:par>
+                          <p:cTn id="8" fill="hold">
+                            <p:stCondLst>
+                              <p:cond delay="0"/>
+                            </p:stCondLst>
+                            <p:childTnLst>
+                              <p:par>
+                                <p:cTn id="9" presetID="1" presetClass="entr" presetSubtype="0" fill="hold" grpId="0" nodeType="clickEffect">
+                                  <p:stCondLst>
+                                    <p:cond delay="0"/>
+                                  </p:stCondLst>
+                                  <p:childTnLst>
+                                    <p:set>
+                                      <p:cBhvr>
+                                        <p:cTn id="10" dur="1" fill="hold">
+                                          <p:stCondLst>
+                                            <p:cond delay="0"/>
+                                          </p:stCondLst>
+                                        </p:cTn>
+                                        <p:tgtEl>
+                                          <p:spTgt spid="3">
+                                            <p:txEl>
+                                              <p:pRg st="1" end="1"/>
+                                            </p:txEl>
+                                          </p:spTgt>
+                                        </p:tgtEl>
+                                        <p:attrNameLst>
+                                          <p:attrName>style.visibility</p:attrName>
+                                        </p:attrNameLst>
+                                      </p:cBhvr>
+                                      <p:to>
+                                        <p:strVal val="visible"/>
+                                      </p:to>
+                                    </p:set>
+                                  </p:childTnLst>
+                                </p:cTn>
+                              </p:par>
+                            </p:childTnLst>
+                          </p:cTn>
+                        </p:par>
+                      </p:childTnLst>
+                    </p:cTn>
+                  </p:par>
+                  <p:par>
+                    <p:cTn id="11" fill="hold">
+                      <p:stCondLst>
+                        <p:cond delay="indefinite"/>
+                      </p:stCondLst>
+                      <p:childTnLst>
+                        <p:par>
+                          <p:cTn id="12" fill="hold">
+                            <p:stCondLst>
+                              <p:cond delay="0"/>
+                            </p:stCondLst>
+                            <p:childTnLst>
+                              <p:par>
+                                <p:cTn id="13" presetID="1" presetClass="entr" presetSubtype="0" fill="hold" grpId="0" nodeType="clickEffect">
+                                  <p:stCondLst>
+                                    <p:cond delay="0"/>
+                                  </p:stCondLst>
+                                  <p:childTnLst>
+                                    <p:set>
+                                      <p:cBhvr>
+                                        <p:cTn id="14" dur="1" fill="hold">
+                                          <p:stCondLst>
+                                            <p:cond delay="0"/>
+                                          </p:stCondLst>
+                                        </p:cTn>
+                                        <p:tgtEl>
+                                          <p:spTgt spid="3">
+                                            <p:txEl>
+                                              <p:pRg st="2" end="2"/>
+                                            </p:txEl>
+                                          </p:spTgt>
+                                        </p:tgtEl>
+                                        <p:attrNameLst>
+                                          <p:attrName>style.visibility</p:attrName>
+                                        </p:attrNameLst>
+                                      </p:cBhvr>
+                                      <p:to>
+                                        <p:strVal val="visible"/>
+                                      </p:to>
+                                    </p:set>
+                                  </p:childTnLst>
+                                </p:cTn>
+                              </p:par>
+                            </p:childTnLst>
+                          </p:cTn>
+                        </p:par>
+                      </p:childTnLst>
+                    </p:cTn>
+                  </p:par>
+                  <p:par>
+                    <p:cTn id="15" fill="hold">
+                      <p:stCondLst>
+                        <p:cond delay="indefinite"/>
+                      </p:stCondLst>
+                      <p:childTnLst>
+                        <p:par>
+                          <p:cTn id="16" fill="hold">
+                            <p:stCondLst>
+                              <p:cond delay="0"/>
+                            </p:stCondLst>
+                            <p:childTnLst>
+                              <p:par>
+                                <p:cTn id="17" presetID="1" presetClass="entr" presetSubtype="0" fill="hold" grpId="0" nodeType="clickEffect">
+                                  <p:stCondLst>
+                                    <p:cond delay="0"/>
+                                  </p:stCondLst>
+                                  <p:childTnLst>
+                                    <p:set>
+                                      <p:cBhvr>
+                                        <p:cTn id="18" dur="1" fill="hold">
+                                          <p:stCondLst>
+                                            <p:cond delay="0"/>
+                                          </p:stCondLst>
+                                        </p:cTn>
+                                        <p:tgtEl>
+                                          <p:spTgt spid="3">
+                                            <p:txEl>
+                                              <p:pRg st="3" end="3"/>
+                                            </p:txEl>
+                                          </p:spTgt>
+                                        </p:tgtEl>
+                                        <p:attrNameLst>
+                                          <p:attrName>style.visibility</p:attrName>
+                                        </p:attrNameLst>
+                                      </p:cBhvr>
+                                      <p:to>
+                                        <p:strVal val="visible"/>
+                                      </p:to>
+                                    </p:set>
+                                  </p:childTnLst>
+                                </p:cTn>
+                              </p:par>
+                            </p:childTnLst>
+                          </p:cTn>
+                        </p:par>
+                      </p:childTnLst>
+                    </p:cTn>
+                  </p:par>
+                  <p:par>
+                    <p:cTn id="19" fill="hold">
+                      <p:stCondLst>
+                        <p:cond delay="indefinite"/>
+                      </p:stCondLst>
+                      <p:childTnLst>
+                        <p:par>
+                          <p:cTn id="20" fill="hold">
+                            <p:stCondLst>
+                              <p:cond delay="0"/>
+                            </p:stCondLst>
+                            <p:childTnLst>
+                              <p:par>
+                                <p:cTn id="21" presetID="1" presetClass="entr" presetSubtype="0" fill="hold" grpId="0" nodeType="clickEffect">
+                                  <p:stCondLst>
+                                    <p:cond delay="0"/>
+                                  </p:stCondLst>
+                                  <p:childTnLst>
+                                    <p:set>
+                                      <p:cBhvr>
+                                        <p:cTn id="22" dur="1" fill="hold">
+                                          <p:stCondLst>
+                                            <p:cond delay="0"/>
+                                          </p:stCondLst>
+                                        </p:cTn>
+                                        <p:tgtEl>
+                                          <p:spTgt spid="3">
+                                            <p:txEl>
+                                              <p:pRg st="4" end="4"/>
+                                            </p:txEl>
+                                          </p:spTgt>
+                                        </p:tgtEl>
+                                        <p:attrNameLst>
+                                          <p:attrName>style.visibility</p:attrName>
+                                        </p:attrNameLst>
+                                      </p:cBhvr>
+                                      <p:to>
+                                        <p:strVal val="visible"/>
+                                      </p:to>
+                                    </p:set>
+                                  </p:childTnLst>
+                                </p:cTn>
+                              </p:par>
+                            </p:childTnLst>
+                          </p:cTn>
+                        </p:par>
+                      </p:childTnLst>
+                    </p:cTn>
+                  </p:par>
+                  <p:par>
+                    <p:cTn id="23" fill="hold">
+                      <p:stCondLst>
+                        <p:cond delay="indefinite"/>
+                      </p:stCondLst>
+                      <p:childTnLst>
+                        <p:par>
+                          <p:cTn id="24" fill="hold">
+                            <p:stCondLst>
+                              <p:cond delay="0"/>
+                            </p:stCondLst>
+                            <p:childTnLst>
+                              <p:par>
+                                <p:cTn id="25" presetID="1" presetClass="entr" presetSubtype="0" fill="hold" grpId="0" nodeType="clickEffect">
+                                  <p:stCondLst>
+                                    <p:cond delay="0"/>
+                                  </p:stCondLst>
+                                  <p:childTnLst>
+                                    <p:set>
+                                      <p:cBhvr>
+                                        <p:cTn id="26" dur="1" fill="hold">
+                                          <p:stCondLst>
+                                            <p:cond delay="0"/>
+                                          </p:stCondLst>
+                                        </p:cTn>
+                                        <p:tgtEl>
+                                          <p:spTgt spid="3">
+                                            <p:txEl>
+                                              <p:pRg st="5" end="5"/>
+                                            </p:txEl>
+                                          </p:spTgt>
+                                        </p:tgtEl>
+                                        <p:attrNameLst>
+                                          <p:attrName>style.visibility</p:attrName>
+                                        </p:attrNameLst>
+                                      </p:cBhvr>
+                                      <p:to>
+                                        <p:strVal val="visible"/>
+                                      </p:to>
+                                    </p:set>
+                                  </p:childTnLst>
+                                </p:cTn>
+                              </p:par>
+                            </p:childTnLst>
+                          </p:cTn>
+                        </p:par>
+                      </p:childTnLst>
+                    </p:cTn>
+                  </p:par>
+                  <p:par>
+                    <p:cTn id="27" fill="hold">
+                      <p:stCondLst>
+                        <p:cond delay="indefinite"/>
+                      </p:stCondLst>
+                      <p:childTnLst>
+                        <p:par>
+                          <p:cTn id="28" fill="hold">
+                            <p:stCondLst>
+                              <p:cond delay="0"/>
+                            </p:stCondLst>
+                            <p:childTnLst>
+                              <p:par>
+                                <p:cTn id="29" presetID="1" presetClass="entr" presetSubtype="0" fill="hold" grpId="0" nodeType="clickEffect">
+                                  <p:stCondLst>
+                                    <p:cond delay="0"/>
+                                  </p:stCondLst>
+                                  <p:childTnLst>
+                                    <p:set>
+                                      <p:cBhvr>
+                                        <p:cTn id="30" dur="1" fill="hold">
+                                          <p:stCondLst>
+                                            <p:cond delay="0"/>
+                                          </p:stCondLst>
+                                        </p:cTn>
+                                        <p:tgtEl>
+                                          <p:spTgt spid="3">
+                                            <p:txEl>
+                                              <p:pRg st="6" end="6"/>
+                                            </p:txEl>
+                                          </p:spTgt>
+                                        </p:tgtEl>
+                                        <p:attrNameLst>
+                                          <p:attrName>style.visibility</p:attrName>
+                                        </p:attrNameLst>
+                                      </p:cBhvr>
+                                      <p:to>
+                                        <p:strVal val="visible"/>
+                                      </p:to>
+                                    </p:set>
+                                  </p:childTnLst>
+                                </p:cTn>
+                              </p:par>
+                            </p:childTnLst>
+                          </p:cTn>
+                        </p:par>
+                      </p:childTnLst>
+                    </p:cTn>
+                  </p:par>
+                  <p:par>
+                    <p:cTn id="31" fill="hold">
+                      <p:stCondLst>
+                        <p:cond delay="indefinite"/>
+                      </p:stCondLst>
+                      <p:childTnLst>
+                        <p:par>
+                          <p:cTn id="32" fill="hold">
+                            <p:stCondLst>
+                              <p:cond delay="0"/>
+                            </p:stCondLst>
+                            <p:childTnLst>
+                              <p:par>
+                                <p:cTn id="33" presetID="1" presetClass="entr" presetSubtype="0" fill="hold" grpId="0" nodeType="clickEffect">
+                                  <p:stCondLst>
+                                    <p:cond delay="0"/>
+                                  </p:stCondLst>
+                                  <p:childTnLst>
+                                    <p:set>
+                                      <p:cBhvr>
+                                        <p:cTn id="34" dur="1" fill="hold">
+                                          <p:stCondLst>
+                                            <p:cond delay="0"/>
+                                          </p:stCondLst>
+                                        </p:cTn>
+                                        <p:tgtEl>
+                                          <p:spTgt spid="3">
+                                            <p:txEl>
+                                              <p:pRg st="7" end="7"/>
+                                            </p:txEl>
+                                          </p:spTgt>
+                                        </p:tgtEl>
+                                        <p:attrNameLst>
+                                          <p:attrName>style.visibility</p:attrName>
+                                        </p:attrNameLst>
+                                      </p:cBhvr>
+                                      <p:to>
+                                        <p:strVal val="visible"/>
+                                      </p:to>
+                                    </p:set>
+                                  </p:childTnLst>
+                                </p:cTn>
+                              </p:par>
+                            </p:childTnLst>
+                          </p:cTn>
+                        </p:par>
+                      </p:childTnLst>
+                    </p:cTn>
+                  </p:par>
+                  <p:par>
+                    <p:cTn id="35" fill="hold">
+                      <p:stCondLst>
+                        <p:cond delay="indefinite"/>
+                      </p:stCondLst>
+                      <p:childTnLst>
+                        <p:par>
+                          <p:cTn id="36" fill="hold">
+                            <p:stCondLst>
+                              <p:cond delay="0"/>
+                            </p:stCondLst>
+                            <p:childTnLst>
+                              <p:par>
+                                <p:cTn id="37" presetID="1" presetClass="entr" presetSubtype="0" fill="hold" grpId="0" nodeType="clickEffect">
+                                  <p:stCondLst>
+                                    <p:cond delay="0"/>
+                                  </p:stCondLst>
+                                  <p:childTnLst>
+                                    <p:set>
+                                      <p:cBhvr>
+                                        <p:cTn id="38" dur="1" fill="hold">
+                                          <p:stCondLst>
+                                            <p:cond delay="0"/>
+                                          </p:stCondLst>
+                                        </p:cTn>
+                                        <p:tgtEl>
+                                          <p:spTgt spid="3">
+                                            <p:txEl>
+                                              <p:pRg st="8" end="8"/>
+                                            </p:txEl>
+                                          </p:spTgt>
+                                        </p:tgtEl>
+                                        <p:attrNameLst>
+                                          <p:attrName>style.visibility</p:attrName>
+                                        </p:attrNameLst>
+                                      </p:cBhvr>
+                                      <p:to>
+                                        <p:strVal val="visible"/>
+                                      </p:to>
+                                    </p:set>
+                                  </p:childTnLst>
+                                </p:cTn>
+                              </p:par>
+                            </p:childTnLst>
+                          </p:cTn>
+                        </p:par>
+                      </p:childTnLst>
+                    </p:cTn>
+                  </p:par>
+                </p:childTnLst>
+              </p:cTn>
+              <p:prevCondLst>
+                <p:cond evt="onPrev" delay="0">
+                  <p:tgtEl>
+                    <p:sldTgt/>
+                  </p:tgtEl>
+                </p:cond>
+              </p:prevCondLst>
+              <p:nextCondLst>
+                <p:cond evt="onNext" delay="0">
+                  <p:tgtEl>
+                    <p:sldTgt/>
+                  </p:tgtEl>
+                </p:cond>
+              </p:nextCondLst>
+            </p:seq>
+          </p:childTnLst>
+        </p:cTn>
+      </p:par>
+    </p:tnLst>
+    <p:bldLst>
+      <p:bldP spid="3" grpId="0" build="p"/>
+    </p:bldLst>
+  </p:timing>
+</p:sld>
+</file>
+
+<file path=ppt/slides/slide26.xml><?xml version="1.0" encoding="utf-8"?>
+<p:sld xmlns:a="http://schemas.openxmlformats.org/drawingml/2006/main" xmlns:r="http://schemas.openxmlformats.org/officeDocument/2006/relationships" xmlns:p="http://schemas.openxmlformats.org/presentationml/2006/main">
+  <p:cSld>
+    <p:spTree>
+      <p:nvGrpSpPr>
+        <p:cNvPr id="1" name=""/>
+        <p:cNvGrpSpPr/>
+        <p:nvPr/>
+      </p:nvGrpSpPr>
+      <p:grpSpPr>
+        <a:xfrm>
+          <a:off x="0" y="0"/>
+          <a:ext cx="0" cy="0"/>
+          <a:chOff x="0" y="0"/>
+          <a:chExt cx="0" cy="0"/>
+        </a:xfrm>
+      </p:grpSpPr>
+      <p:sp>
+        <p:nvSpPr>
+          <p:cNvPr id="2" name="Title 1">
+            <a:extLst>
+              <a:ext uri="{FF2B5EF4-FFF2-40B4-BE49-F238E27FC236}">
+                <a16:creationId xmlns:a16="http://schemas.microsoft.com/office/drawing/2014/main" id="{A93AD8D0-6DB4-575E-917E-EF1716356808}"/>
+              </a:ext>
+            </a:extLst>
+          </p:cNvPr>
+          <p:cNvSpPr>
+            <a:spLocks noGrp="1"/>
+          </p:cNvSpPr>
+          <p:nvPr>
+            <p:ph type="ctrTitle"/>
+          </p:nvPr>
+        </p:nvSpPr>
+        <p:spPr/>
+        <p:txBody>
+          <a:bodyPr/>
+          <a:lstStyle/>
+          <a:p>
+            <a:endParaRPr lang="et-EE" dirty="0"/>
+          </a:p>
+        </p:txBody>
+      </p:sp>
+      <p:sp>
+        <p:nvSpPr>
+          <p:cNvPr id="3" name="Content Placeholder 2">
+            <a:extLst>
+              <a:ext uri="{FF2B5EF4-FFF2-40B4-BE49-F238E27FC236}">
+                <a16:creationId xmlns:a16="http://schemas.microsoft.com/office/drawing/2014/main" id="{4A604898-1A89-32D0-7964-55457B42E945}"/>
+              </a:ext>
+            </a:extLst>
+          </p:cNvPr>
+          <p:cNvSpPr>
+            <a:spLocks noGrp="1"/>
+          </p:cNvSpPr>
+          <p:nvPr>
+            <p:ph sz="quarter" idx="10"/>
+          </p:nvPr>
+        </p:nvSpPr>
+        <p:spPr/>
+        <p:txBody>
+          <a:bodyPr/>
+          <a:lstStyle/>
+          <a:p>
+            <a:endParaRPr lang="en-US" dirty="0"/>
+          </a:p>
+          <a:p>
+            <a:endParaRPr lang="en-US" dirty="0"/>
+          </a:p>
+          <a:p>
+            <a:endParaRPr lang="en-US" dirty="0"/>
+          </a:p>
+          <a:p>
+            <a:endParaRPr lang="en-US" dirty="0"/>
+          </a:p>
+          <a:p>
+            <a:endParaRPr lang="en-US" dirty="0"/>
+          </a:p>
+          <a:p>
+            <a:endParaRPr lang="en-US" dirty="0"/>
+          </a:p>
+          <a:p>
+            <a:r>
+              <a:rPr lang="en-US" sz="2400" dirty="0" err="1"/>
+              <a:t>Leppime</a:t>
+            </a:r>
+            <a:r>
+              <a:rPr lang="en-US" sz="2400" dirty="0"/>
+              <a:t> </a:t>
+            </a:r>
+            <a:r>
+              <a:rPr lang="en-US" sz="2400" dirty="0" err="1"/>
+              <a:t>kokku</a:t>
+            </a:r>
+            <a:r>
+              <a:rPr lang="en-US" sz="2400" dirty="0"/>
+              <a:t> </a:t>
+            </a:r>
+            <a:r>
+              <a:rPr lang="en-US" sz="2400" dirty="0" err="1"/>
+              <a:t>kohtumised</a:t>
+            </a:r>
+            <a:r>
+              <a:rPr lang="en-US" sz="2400" dirty="0"/>
+              <a:t> </a:t>
+            </a:r>
+            <a:r>
+              <a:rPr lang="en-US" sz="2400" dirty="0" err="1"/>
+              <a:t>kliendiga</a:t>
+            </a:r>
+            <a:endParaRPr lang="et-EE" sz="2400" dirty="0"/>
+          </a:p>
+        </p:txBody>
+      </p:sp>
+    </p:spTree>
+    <p:extLst>
+      <p:ext uri="{BB962C8B-B14F-4D97-AF65-F5344CB8AC3E}">
+        <p14:creationId xmlns:p14="http://schemas.microsoft.com/office/powerpoint/2010/main" val="1519353560"/>
       </p:ext>
     </p:extLst>
   </p:cSld>
@@ -45389,6 +48228,12 @@
 </file>
 
 <file path=customXml/item1.xml><?xml version="1.0" encoding="utf-8"?>
+<p:properties xmlns:p="http://schemas.microsoft.com/office/2006/metadata/properties" xmlns:xsi="http://www.w3.org/2001/XMLSchema-instance" xmlns:pc="http://schemas.microsoft.com/office/infopath/2007/PartnerControls">
+  <documentManagement/>
+</p:properties>
+</file>
+
+<file path=customXml/item2.xml><?xml version="1.0" encoding="utf-8"?>
 <ct:contentTypeSchema xmlns:ct="http://schemas.microsoft.com/office/2006/metadata/contentType" xmlns:ma="http://schemas.microsoft.com/office/2006/metadata/properties/metaAttributes" ct:_="" ma:_="" ma:contentTypeName="Document" ma:contentTypeID="0x010100C4D27B8FA8976546BCD79313C588588D" ma:contentTypeVersion="8" ma:contentTypeDescription="Create a new document." ma:contentTypeScope="" ma:versionID="a112c56f6fe148a79025c76584832af0">
   <xsd:schema xmlns:xsd="http://www.w3.org/2001/XMLSchema" xmlns:xs="http://www.w3.org/2001/XMLSchema" xmlns:p="http://schemas.microsoft.com/office/2006/metadata/properties" xmlns:ns2="a1a2d923-8fea-42f1-bd41-9cdfff65694e" targetNamespace="http://schemas.microsoft.com/office/2006/metadata/properties" ma:root="true" ma:fieldsID="97c8655d467eaa9470a714421e7268c0" ns2:_="">
     <xsd:import namespace="a1a2d923-8fea-42f1-bd41-9cdfff65694e"/>
@@ -45556,12 +48401,6 @@
 </ct:contentTypeSchema>
 </file>
 
-<file path=customXml/item2.xml><?xml version="1.0" encoding="utf-8"?>
-<p:properties xmlns:p="http://schemas.microsoft.com/office/2006/metadata/properties" xmlns:xsi="http://www.w3.org/2001/XMLSchema-instance" xmlns:pc="http://schemas.microsoft.com/office/infopath/2007/PartnerControls">
-  <documentManagement/>
-</p:properties>
-</file>
-
 <file path=customXml/item3.xml><?xml version="1.0" encoding="utf-8"?>
 <?mso-contentType ?>
 <FormTemplates xmlns="http://schemas.microsoft.com/sharepoint/v3/contenttype/forms">
@@ -45572,6 +48411,15 @@
 </file>
 
 <file path=customXml/itemProps1.xml><?xml version="1.0" encoding="utf-8"?>
+<ds:datastoreItem xmlns:ds="http://schemas.openxmlformats.org/officeDocument/2006/customXml" ds:itemID="{5BDF4908-A52A-47DD-A794-6E02D71942FC}">
+  <ds:schemaRefs>
+    <ds:schemaRef ds:uri="http://schemas.microsoft.com/office/2006/metadata/properties"/>
+    <ds:schemaRef ds:uri="http://schemas.microsoft.com/office/infopath/2007/PartnerControls"/>
+  </ds:schemaRefs>
+</ds:datastoreItem>
+</file>
+
+<file path=customXml/itemProps2.xml><?xml version="1.0" encoding="utf-8"?>
 <ds:datastoreItem xmlns:ds="http://schemas.openxmlformats.org/officeDocument/2006/customXml" ds:itemID="{9CF4F972-2392-44D0-AA45-41AC4FDC4A59}">
   <ds:schemaRefs>
     <ds:schemaRef ds:uri="a1a2d923-8fea-42f1-bd41-9cdfff65694e"/>
@@ -45589,15 +48437,6 @@
 </ds:datastoreItem>
 </file>
 
-<file path=customXml/itemProps2.xml><?xml version="1.0" encoding="utf-8"?>
-<ds:datastoreItem xmlns:ds="http://schemas.openxmlformats.org/officeDocument/2006/customXml" ds:itemID="{5BDF4908-A52A-47DD-A794-6E02D71942FC}">
-  <ds:schemaRefs>
-    <ds:schemaRef ds:uri="http://schemas.microsoft.com/office/2006/metadata/properties"/>
-    <ds:schemaRef ds:uri="http://schemas.microsoft.com/office/infopath/2007/PartnerControls"/>
-  </ds:schemaRefs>
-</ds:datastoreItem>
-</file>
-
 <file path=customXml/itemProps3.xml><?xml version="1.0" encoding="utf-8"?>
 <ds:datastoreItem xmlns:ds="http://schemas.openxmlformats.org/officeDocument/2006/customXml" ds:itemID="{9DC439CA-6F1C-4005-ACA6-A52E04DEE0A7}">
   <ds:schemaRefs>

</xml_diff>